<commit_message>
updated slides for week 2
</commit_message>
<xml_diff>
--- a/Slides/Week 2. Niches_and_Distributions_a.pptx
+++ b/Slides/Week 2. Niches_and_Distributions_a.pptx
@@ -5,10 +5,10 @@
     <p:sldMasterId id="2147483648" r:id="rId1"/>
   </p:sldMasterIdLst>
   <p:notesMasterIdLst>
-    <p:notesMasterId r:id="rId17"/>
+    <p:notesMasterId r:id="rId34"/>
   </p:notesMasterIdLst>
   <p:handoutMasterIdLst>
-    <p:handoutMasterId r:id="rId18"/>
+    <p:handoutMasterId r:id="rId35"/>
   </p:handoutMasterIdLst>
   <p:sldIdLst>
     <p:sldId id="256" r:id="rId2"/>
@@ -26,6 +26,23 @@
     <p:sldId id="526" r:id="rId14"/>
     <p:sldId id="522" r:id="rId15"/>
     <p:sldId id="516" r:id="rId16"/>
+    <p:sldId id="531" r:id="rId17"/>
+    <p:sldId id="532" r:id="rId18"/>
+    <p:sldId id="513" r:id="rId19"/>
+    <p:sldId id="533" r:id="rId20"/>
+    <p:sldId id="496" r:id="rId21"/>
+    <p:sldId id="534" r:id="rId22"/>
+    <p:sldId id="535" r:id="rId23"/>
+    <p:sldId id="536" r:id="rId24"/>
+    <p:sldId id="508" r:id="rId25"/>
+    <p:sldId id="499" r:id="rId26"/>
+    <p:sldId id="500" r:id="rId27"/>
+    <p:sldId id="537" r:id="rId28"/>
+    <p:sldId id="506" r:id="rId29"/>
+    <p:sldId id="501" r:id="rId30"/>
+    <p:sldId id="504" r:id="rId31"/>
+    <p:sldId id="511" r:id="rId32"/>
+    <p:sldId id="509" r:id="rId33"/>
   </p:sldIdLst>
   <p:sldSz cx="9144000" cy="6858000" type="screen4x3"/>
   <p:notesSz cx="6858000" cy="9144000"/>
@@ -144,6 +161,23 @@
             <p14:sldId id="526"/>
             <p14:sldId id="522"/>
             <p14:sldId id="516"/>
+            <p14:sldId id="531"/>
+            <p14:sldId id="532"/>
+            <p14:sldId id="513"/>
+            <p14:sldId id="533"/>
+            <p14:sldId id="496"/>
+            <p14:sldId id="534"/>
+            <p14:sldId id="535"/>
+            <p14:sldId id="536"/>
+            <p14:sldId id="508"/>
+            <p14:sldId id="499"/>
+            <p14:sldId id="500"/>
+            <p14:sldId id="537"/>
+            <p14:sldId id="506"/>
+            <p14:sldId id="501"/>
+            <p14:sldId id="504"/>
+            <p14:sldId id="511"/>
+            <p14:sldId id="509"/>
           </p14:sldIdLst>
         </p14:section>
       </p14:sectionLst>
@@ -269,7 +303,7 @@
           <a:p>
             <a:fld id="{5D8404FB-D815-9B49-9DBC-B684E3C0E790}" type="datetimeFigureOut">
               <a:rPr lang="en-US" smtClean="0"/>
-              <a:t>9/1/26</a:t>
+              <a:t>9/3/26</a:t>
             </a:fld>
             <a:endParaRPr lang="en-US"/>
           </a:p>
@@ -446,7 +480,7 @@
           <a:p>
             <a:fld id="{18AC5A93-540D-2443-A380-5679C155FF14}" type="datetimeFigureOut">
               <a:rPr lang="en-US" smtClean="0"/>
-              <a:t>9/1/26</a:t>
+              <a:t>9/3/26</a:t>
             </a:fld>
             <a:endParaRPr lang="en-US"/>
           </a:p>
@@ -713,6 +747,90 @@
 </p:notesMaster>
 </file>
 
+<file path=ppt/notesSlides/notesSlide1.xml><?xml version="1.0" encoding="utf-8"?>
+<p:notes xmlns:a="http://schemas.openxmlformats.org/drawingml/2006/main" xmlns:r="http://schemas.openxmlformats.org/officeDocument/2006/relationships" xmlns:p="http://schemas.openxmlformats.org/presentationml/2006/main">
+  <p:cSld>
+    <p:spTree>
+      <p:nvGrpSpPr>
+        <p:cNvPr id="1" name=""/>
+        <p:cNvGrpSpPr/>
+        <p:nvPr/>
+      </p:nvGrpSpPr>
+      <p:grpSpPr>
+        <a:xfrm>
+          <a:off x="0" y="0"/>
+          <a:ext cx="0" cy="0"/>
+          <a:chOff x="0" y="0"/>
+          <a:chExt cx="0" cy="0"/>
+        </a:xfrm>
+      </p:grpSpPr>
+      <p:sp>
+        <p:nvSpPr>
+          <p:cNvPr id="2" name="Slide Image Placeholder 1"/>
+          <p:cNvSpPr>
+            <a:spLocks noGrp="1" noRot="1" noChangeAspect="1"/>
+          </p:cNvSpPr>
+          <p:nvPr>
+            <p:ph type="sldImg"/>
+          </p:nvPr>
+        </p:nvSpPr>
+        <p:spPr/>
+      </p:sp>
+      <p:sp>
+        <p:nvSpPr>
+          <p:cNvPr id="3" name="Notes Placeholder 2"/>
+          <p:cNvSpPr>
+            <a:spLocks noGrp="1"/>
+          </p:cNvSpPr>
+          <p:nvPr>
+            <p:ph type="body" idx="1"/>
+          </p:nvPr>
+        </p:nvSpPr>
+        <p:spPr/>
+        <p:txBody>
+          <a:bodyPr/>
+          <a:lstStyle/>
+          <a:p>
+            <a:endParaRPr lang="en-US" dirty="0"/>
+          </a:p>
+        </p:txBody>
+      </p:sp>
+      <p:sp>
+        <p:nvSpPr>
+          <p:cNvPr id="4" name="Slide Number Placeholder 3"/>
+          <p:cNvSpPr>
+            <a:spLocks noGrp="1"/>
+          </p:cNvSpPr>
+          <p:nvPr>
+            <p:ph type="sldNum" sz="quarter" idx="5"/>
+          </p:nvPr>
+        </p:nvSpPr>
+        <p:spPr/>
+        <p:txBody>
+          <a:bodyPr/>
+          <a:lstStyle/>
+          <a:p>
+            <a:fld id="{100A90D5-3B1D-1149-800E-15EBB2932B0B}" type="slidenum">
+              <a:rPr lang="en-US" smtClean="0"/>
+              <a:t>25</a:t>
+            </a:fld>
+            <a:endParaRPr lang="en-US"/>
+          </a:p>
+        </p:txBody>
+      </p:sp>
+    </p:spTree>
+    <p:extLst>
+      <p:ext uri="{BB962C8B-B14F-4D97-AF65-F5344CB8AC3E}">
+        <p14:creationId xmlns:p14="http://schemas.microsoft.com/office/powerpoint/2010/main" val="4242784174"/>
+      </p:ext>
+    </p:extLst>
+  </p:cSld>
+  <p:clrMapOvr>
+    <a:masterClrMapping/>
+  </p:clrMapOvr>
+</p:notes>
+</file>
+
 <file path=ppt/slideLayouts/slideLayout1.xml><?xml version="1.0" encoding="utf-8"?>
 <p:sldLayout xmlns:a="http://schemas.openxmlformats.org/drawingml/2006/main" xmlns:r="http://schemas.openxmlformats.org/officeDocument/2006/relationships" xmlns:p="http://schemas.openxmlformats.org/presentationml/2006/main" type="title" preserve="1">
   <p:cSld name="Title Slide">
@@ -1026,7 +1144,7 @@
           <a:p>
             <a:fld id="{D19067CA-FF63-4940-92DF-E3096929B04A}" type="datetimeFigureOut">
               <a:rPr lang="en-US" smtClean="0"/>
-              <a:t>9/1/26</a:t>
+              <a:t>9/3/26</a:t>
             </a:fld>
             <a:endParaRPr lang="en-US"/>
           </a:p>
@@ -1220,7 +1338,7 @@
           <a:p>
             <a:fld id="{D19067CA-FF63-4940-92DF-E3096929B04A}" type="datetimeFigureOut">
               <a:rPr lang="en-US" smtClean="0"/>
-              <a:t>9/1/26</a:t>
+              <a:t>9/3/26</a:t>
             </a:fld>
             <a:endParaRPr lang="en-US"/>
           </a:p>
@@ -1404,7 +1522,7 @@
           <a:p>
             <a:fld id="{D19067CA-FF63-4940-92DF-E3096929B04A}" type="datetimeFigureOut">
               <a:rPr lang="en-US" smtClean="0"/>
-              <a:t>9/1/26</a:t>
+              <a:t>9/3/26</a:t>
             </a:fld>
             <a:endParaRPr lang="en-US"/>
           </a:p>
@@ -1665,7 +1783,7 @@
           <a:p>
             <a:fld id="{D19067CA-FF63-4940-92DF-E3096929B04A}" type="datetimeFigureOut">
               <a:rPr lang="en-US" smtClean="0"/>
-              <a:t>9/1/26</a:t>
+              <a:t>9/3/26</a:t>
             </a:fld>
             <a:endParaRPr lang="en-US"/>
           </a:p>
@@ -1966,7 +2084,7 @@
           <a:p>
             <a:fld id="{D19067CA-FF63-4940-92DF-E3096929B04A}" type="datetimeFigureOut">
               <a:rPr lang="en-US" smtClean="0"/>
-              <a:t>9/1/26</a:t>
+              <a:t>9/3/26</a:t>
             </a:fld>
             <a:endParaRPr lang="en-US"/>
           </a:p>
@@ -2401,7 +2519,7 @@
           <a:p>
             <a:fld id="{D19067CA-FF63-4940-92DF-E3096929B04A}" type="datetimeFigureOut">
               <a:rPr lang="en-US" smtClean="0"/>
-              <a:t>9/1/26</a:t>
+              <a:t>9/3/26</a:t>
             </a:fld>
             <a:endParaRPr lang="en-US"/>
           </a:p>
@@ -2534,7 +2652,7 @@
           <a:p>
             <a:fld id="{D19067CA-FF63-4940-92DF-E3096929B04A}" type="datetimeFigureOut">
               <a:rPr lang="en-US" smtClean="0"/>
-              <a:t>9/1/26</a:t>
+              <a:t>9/3/26</a:t>
             </a:fld>
             <a:endParaRPr lang="en-US"/>
           </a:p>
@@ -2645,7 +2763,7 @@
           <a:p>
             <a:fld id="{D19067CA-FF63-4940-92DF-E3096929B04A}" type="datetimeFigureOut">
               <a:rPr lang="en-US" smtClean="0"/>
-              <a:t>9/1/26</a:t>
+              <a:t>9/3/26</a:t>
             </a:fld>
             <a:endParaRPr lang="en-US"/>
           </a:p>
@@ -2936,7 +3054,7 @@
           <a:p>
             <a:fld id="{D19067CA-FF63-4940-92DF-E3096929B04A}" type="datetimeFigureOut">
               <a:rPr lang="en-US" smtClean="0"/>
-              <a:t>9/1/26</a:t>
+              <a:t>9/3/26</a:t>
             </a:fld>
             <a:endParaRPr lang="en-US"/>
           </a:p>
@@ -3204,7 +3322,7 @@
           <a:p>
             <a:fld id="{D19067CA-FF63-4940-92DF-E3096929B04A}" type="datetimeFigureOut">
               <a:rPr lang="en-US" smtClean="0"/>
-              <a:t>9/1/26</a:t>
+              <a:t>9/3/26</a:t>
             </a:fld>
             <a:endParaRPr lang="en-US"/>
           </a:p>
@@ -7222,6 +7340,476 @@
 </p:sld>
 </file>
 
+<file path=ppt/slides/slide16.xml><?xml version="1.0" encoding="utf-8"?>
+<p:sld xmlns:a="http://schemas.openxmlformats.org/drawingml/2006/main" xmlns:r="http://schemas.openxmlformats.org/officeDocument/2006/relationships" xmlns:p="http://schemas.openxmlformats.org/presentationml/2006/main">
+  <p:cSld>
+    <p:spTree>
+      <p:nvGrpSpPr>
+        <p:cNvPr id="1" name=""/>
+        <p:cNvGrpSpPr/>
+        <p:nvPr/>
+      </p:nvGrpSpPr>
+      <p:grpSpPr>
+        <a:xfrm>
+          <a:off x="0" y="0"/>
+          <a:ext cx="0" cy="0"/>
+          <a:chOff x="0" y="0"/>
+          <a:chExt cx="0" cy="0"/>
+        </a:xfrm>
+      </p:grpSpPr>
+      <p:sp>
+        <p:nvSpPr>
+          <p:cNvPr id="2" name="Title 1">
+            <a:extLst>
+              <a:ext uri="{FF2B5EF4-FFF2-40B4-BE49-F238E27FC236}">
+                <a16:creationId xmlns:a16="http://schemas.microsoft.com/office/drawing/2014/main" id="{886F4386-CA81-98D9-93AB-3055D13D5C55}"/>
+              </a:ext>
+            </a:extLst>
+          </p:cNvPr>
+          <p:cNvSpPr>
+            <a:spLocks noGrp="1"/>
+          </p:cNvSpPr>
+          <p:nvPr>
+            <p:ph type="title"/>
+          </p:nvPr>
+        </p:nvSpPr>
+        <p:spPr/>
+        <p:txBody>
+          <a:bodyPr/>
+          <a:lstStyle/>
+          <a:p>
+            <a:endParaRPr lang="en-US"/>
+          </a:p>
+        </p:txBody>
+      </p:sp>
+      <p:sp>
+        <p:nvSpPr>
+          <p:cNvPr id="3" name="Content Placeholder 2">
+            <a:extLst>
+              <a:ext uri="{FF2B5EF4-FFF2-40B4-BE49-F238E27FC236}">
+                <a16:creationId xmlns:a16="http://schemas.microsoft.com/office/drawing/2014/main" id="{6FF2799F-F8E9-F7C0-3D53-9235F2911641}"/>
+              </a:ext>
+            </a:extLst>
+          </p:cNvPr>
+          <p:cNvSpPr>
+            <a:spLocks noGrp="1"/>
+          </p:cNvSpPr>
+          <p:nvPr>
+            <p:ph idx="1"/>
+          </p:nvPr>
+        </p:nvSpPr>
+        <p:spPr/>
+        <p:txBody>
+          <a:bodyPr/>
+          <a:lstStyle/>
+          <a:p>
+            <a:endParaRPr lang="en-US"/>
+          </a:p>
+        </p:txBody>
+      </p:sp>
+    </p:spTree>
+    <p:extLst>
+      <p:ext uri="{BB962C8B-B14F-4D97-AF65-F5344CB8AC3E}">
+        <p14:creationId xmlns:p14="http://schemas.microsoft.com/office/powerpoint/2010/main" val="1250520718"/>
+      </p:ext>
+    </p:extLst>
+  </p:cSld>
+  <p:clrMapOvr>
+    <a:masterClrMapping/>
+  </p:clrMapOvr>
+</p:sld>
+</file>
+
+<file path=ppt/slides/slide17.xml><?xml version="1.0" encoding="utf-8"?>
+<p:sld xmlns:a="http://schemas.openxmlformats.org/drawingml/2006/main" xmlns:r="http://schemas.openxmlformats.org/officeDocument/2006/relationships" xmlns:p="http://schemas.openxmlformats.org/presentationml/2006/main">
+  <p:cSld>
+    <p:spTree>
+      <p:nvGrpSpPr>
+        <p:cNvPr id="1" name=""/>
+        <p:cNvGrpSpPr/>
+        <p:nvPr/>
+      </p:nvGrpSpPr>
+      <p:grpSpPr>
+        <a:xfrm>
+          <a:off x="0" y="0"/>
+          <a:ext cx="0" cy="0"/>
+          <a:chOff x="0" y="0"/>
+          <a:chExt cx="0" cy="0"/>
+        </a:xfrm>
+      </p:grpSpPr>
+      <p:sp>
+        <p:nvSpPr>
+          <p:cNvPr id="4" name="Title 1">
+            <a:extLst>
+              <a:ext uri="{FF2B5EF4-FFF2-40B4-BE49-F238E27FC236}">
+                <a16:creationId xmlns:a16="http://schemas.microsoft.com/office/drawing/2014/main" id="{4A580449-4DBE-793E-47E9-0226D1CA1F41}"/>
+              </a:ext>
+            </a:extLst>
+          </p:cNvPr>
+          <p:cNvSpPr txBox="1">
+            <a:spLocks/>
+          </p:cNvSpPr>
+          <p:nvPr/>
+        </p:nvSpPr>
+        <p:spPr>
+          <a:xfrm>
+            <a:off x="1222744" y="2857500"/>
+            <a:ext cx="7038754" cy="1143000"/>
+          </a:xfrm>
+          <a:prstGeom prst="rect">
+            <a:avLst/>
+          </a:prstGeom>
+        </p:spPr>
+        <p:txBody>
+          <a:bodyPr vert="horz" lIns="91440" tIns="45720" rIns="91440" bIns="45720" rtlCol="0" anchor="ctr">
+            <a:normAutofit/>
+          </a:bodyPr>
+          <a:lstStyle>
+            <a:lvl1pPr algn="l" defTabSz="457200" rtl="0" eaLnBrk="1" latinLnBrk="0" hangingPunct="1">
+              <a:spcBef>
+                <a:spcPct val="0"/>
+              </a:spcBef>
+              <a:buNone/>
+              <a:defRPr sz="3600" kern="1200">
+                <a:solidFill>
+                  <a:srgbClr val="800000"/>
+                </a:solidFill>
+                <a:latin typeface="+mj-lt"/>
+                <a:ea typeface="+mj-ea"/>
+                <a:cs typeface="+mj-cs"/>
+              </a:defRPr>
+            </a:lvl1pPr>
+          </a:lstStyle>
+          <a:p>
+            <a:r>
+              <a:rPr lang="en-US"/>
+              <a:t>Niches and Geographic Distributions</a:t>
+            </a:r>
+            <a:endParaRPr lang="en-US" dirty="0"/>
+          </a:p>
+        </p:txBody>
+      </p:sp>
+    </p:spTree>
+    <p:extLst>
+      <p:ext uri="{BB962C8B-B14F-4D97-AF65-F5344CB8AC3E}">
+        <p14:creationId xmlns:p14="http://schemas.microsoft.com/office/powerpoint/2010/main" val="4048111539"/>
+      </p:ext>
+    </p:extLst>
+  </p:cSld>
+  <p:clrMapOvr>
+    <a:masterClrMapping/>
+  </p:clrMapOvr>
+</p:sld>
+</file>
+
+<file path=ppt/slides/slide18.xml><?xml version="1.0" encoding="utf-8"?>
+<p:sld xmlns:a="http://schemas.openxmlformats.org/drawingml/2006/main" xmlns:r="http://schemas.openxmlformats.org/officeDocument/2006/relationships" xmlns:p="http://schemas.openxmlformats.org/presentationml/2006/main">
+  <p:cSld>
+    <p:spTree>
+      <p:nvGrpSpPr>
+        <p:cNvPr id="1" name=""/>
+        <p:cNvGrpSpPr/>
+        <p:nvPr/>
+      </p:nvGrpSpPr>
+      <p:grpSpPr>
+        <a:xfrm>
+          <a:off x="0" y="0"/>
+          <a:ext cx="0" cy="0"/>
+          <a:chOff x="0" y="0"/>
+          <a:chExt cx="0" cy="0"/>
+        </a:xfrm>
+      </p:grpSpPr>
+      <p:pic>
+        <p:nvPicPr>
+          <p:cNvPr id="1026" name="Picture 2" descr="https://www.researchgate.net/profile/Carsten_Meyer/publication/303973249/figure/fig1/AS:373144356442112@1465975955922/Range-maps-point-occurrence-records-and-species-level-information-metrics-for-eight.png">
+            <a:extLst>
+              <a:ext uri="{FF2B5EF4-FFF2-40B4-BE49-F238E27FC236}">
+                <a16:creationId xmlns:a16="http://schemas.microsoft.com/office/drawing/2014/main" id="{1864FD2C-8093-0742-987A-D6419E82F482}"/>
+              </a:ext>
+            </a:extLst>
+          </p:cNvPr>
+          <p:cNvPicPr>
+            <a:picLocks noChangeAspect="1" noChangeArrowheads="1"/>
+          </p:cNvPicPr>
+          <p:nvPr/>
+        </p:nvPicPr>
+        <p:blipFill>
+          <a:blip r:embed="rId2">
+            <a:extLst>
+              <a:ext uri="{28A0092B-C50C-407E-A947-70E740481C1C}">
+                <a14:useLocalDpi xmlns:a14="http://schemas.microsoft.com/office/drawing/2010/main" val="0"/>
+              </a:ext>
+            </a:extLst>
+          </a:blip>
+          <a:srcRect/>
+          <a:stretch>
+            <a:fillRect/>
+          </a:stretch>
+        </p:blipFill>
+        <p:spPr bwMode="auto">
+          <a:xfrm>
+            <a:off x="358152" y="1566340"/>
+            <a:ext cx="8408837" cy="4283251"/>
+          </a:xfrm>
+          <a:prstGeom prst="rect">
+            <a:avLst/>
+          </a:prstGeom>
+          <a:noFill/>
+          <a:extLst>
+            <a:ext uri="{909E8E84-426E-40DD-AFC4-6F175D3DCCD1}">
+              <a14:hiddenFill xmlns:a14="http://schemas.microsoft.com/office/drawing/2010/main">
+                <a:solidFill>
+                  <a:srgbClr val="FFFFFF"/>
+                </a:solidFill>
+              </a14:hiddenFill>
+            </a:ext>
+          </a:extLst>
+        </p:spPr>
+      </p:pic>
+      <p:sp>
+        <p:nvSpPr>
+          <p:cNvPr id="4" name="TextBox 3">
+            <a:extLst>
+              <a:ext uri="{FF2B5EF4-FFF2-40B4-BE49-F238E27FC236}">
+                <a16:creationId xmlns:a16="http://schemas.microsoft.com/office/drawing/2014/main" id="{6ADBDE27-C6D7-AA4B-9C59-78DF2BCBDFC0}"/>
+              </a:ext>
+            </a:extLst>
+          </p:cNvPr>
+          <p:cNvSpPr txBox="1"/>
+          <p:nvPr/>
+        </p:nvSpPr>
+        <p:spPr>
+          <a:xfrm>
+            <a:off x="1003236" y="6211669"/>
+            <a:ext cx="7525752" cy="646331"/>
+          </a:xfrm>
+          <a:prstGeom prst="rect">
+            <a:avLst/>
+          </a:prstGeom>
+          <a:noFill/>
+        </p:spPr>
+        <p:txBody>
+          <a:bodyPr wrap="square" rtlCol="0">
+            <a:spAutoFit/>
+          </a:bodyPr>
+          <a:lstStyle/>
+          <a:p>
+            <a:r>
+              <a:rPr lang="en-US" sz="1200" dirty="0"/>
+              <a:t>Meyer et al. (2016) Range geometry and socio-economics dominate species-level biases in occurrence information. </a:t>
+            </a:r>
+            <a:r>
+              <a:rPr lang="en-US" sz="1200" i="1" dirty="0"/>
+              <a:t>Global Ecol. </a:t>
+            </a:r>
+            <a:r>
+              <a:rPr lang="en-US" sz="1200" i="1" dirty="0" err="1"/>
+              <a:t>Biogeogr</a:t>
+            </a:r>
+            <a:r>
+              <a:rPr lang="en-US" sz="1200" i="1" dirty="0"/>
+              <a:t>. </a:t>
+            </a:r>
+            <a:r>
+              <a:rPr lang="en-US" sz="1200" dirty="0"/>
+              <a:t>25: 1181-1193.</a:t>
+            </a:r>
+          </a:p>
+          <a:p>
+            <a:endParaRPr lang="en-US" sz="1200" dirty="0"/>
+          </a:p>
+        </p:txBody>
+      </p:sp>
+      <p:sp>
+        <p:nvSpPr>
+          <p:cNvPr id="2" name="Title 1">
+            <a:extLst>
+              <a:ext uri="{FF2B5EF4-FFF2-40B4-BE49-F238E27FC236}">
+                <a16:creationId xmlns:a16="http://schemas.microsoft.com/office/drawing/2014/main" id="{24EFBE3F-A164-8E40-6CCA-65A8A1EAC7BD}"/>
+              </a:ext>
+            </a:extLst>
+          </p:cNvPr>
+          <p:cNvSpPr>
+            <a:spLocks noGrp="1"/>
+          </p:cNvSpPr>
+          <p:nvPr>
+            <p:ph type="title"/>
+          </p:nvPr>
+        </p:nvSpPr>
+        <p:spPr>
+          <a:xfrm>
+            <a:off x="398276" y="430741"/>
+            <a:ext cx="8151977" cy="1143000"/>
+          </a:xfrm>
+        </p:spPr>
+        <p:txBody>
+          <a:bodyPr>
+            <a:normAutofit/>
+          </a:bodyPr>
+          <a:lstStyle/>
+          <a:p>
+            <a:r>
+              <a:rPr lang="en-US" sz="2600" dirty="0">
+                <a:solidFill>
+                  <a:schemeClr val="accent2">
+                    <a:lumMod val="50000"/>
+                  </a:schemeClr>
+                </a:solidFill>
+              </a:rPr>
+              <a:t>Observed records reflect sampling effort as well as biology</a:t>
+            </a:r>
+          </a:p>
+        </p:txBody>
+      </p:sp>
+    </p:spTree>
+    <p:extLst>
+      <p:ext uri="{BB962C8B-B14F-4D97-AF65-F5344CB8AC3E}">
+        <p14:creationId xmlns:p14="http://schemas.microsoft.com/office/powerpoint/2010/main" val="3139011331"/>
+      </p:ext>
+    </p:extLst>
+  </p:cSld>
+  <p:clrMapOvr>
+    <a:masterClrMapping/>
+  </p:clrMapOvr>
+</p:sld>
+</file>
+
+<file path=ppt/slides/slide19.xml><?xml version="1.0" encoding="utf-8"?>
+<p:sld xmlns:a="http://schemas.openxmlformats.org/drawingml/2006/main" xmlns:r="http://schemas.openxmlformats.org/officeDocument/2006/relationships" xmlns:p="http://schemas.openxmlformats.org/presentationml/2006/main">
+  <p:cSld>
+    <p:spTree>
+      <p:nvGrpSpPr>
+        <p:cNvPr id="1" name=""/>
+        <p:cNvGrpSpPr/>
+        <p:nvPr/>
+      </p:nvGrpSpPr>
+      <p:grpSpPr>
+        <a:xfrm>
+          <a:off x="0" y="0"/>
+          <a:ext cx="0" cy="0"/>
+          <a:chOff x="0" y="0"/>
+          <a:chExt cx="0" cy="0"/>
+        </a:xfrm>
+      </p:grpSpPr>
+      <p:sp>
+        <p:nvSpPr>
+          <p:cNvPr id="2" name="Title 1">
+            <a:extLst>
+              <a:ext uri="{FF2B5EF4-FFF2-40B4-BE49-F238E27FC236}">
+                <a16:creationId xmlns:a16="http://schemas.microsoft.com/office/drawing/2014/main" id="{95703EE2-3479-DA4D-45C8-E2BF164F320B}"/>
+              </a:ext>
+            </a:extLst>
+          </p:cNvPr>
+          <p:cNvSpPr>
+            <a:spLocks noGrp="1"/>
+          </p:cNvSpPr>
+          <p:nvPr>
+            <p:ph type="title"/>
+          </p:nvPr>
+        </p:nvSpPr>
+        <p:spPr/>
+        <p:txBody>
+          <a:bodyPr/>
+          <a:lstStyle/>
+          <a:p>
+            <a:r>
+              <a:rPr lang="en-US" dirty="0"/>
+              <a:t>Geographic distributions</a:t>
+            </a:r>
+          </a:p>
+        </p:txBody>
+      </p:sp>
+      <p:sp>
+        <p:nvSpPr>
+          <p:cNvPr id="3" name="Content Placeholder 2">
+            <a:extLst>
+              <a:ext uri="{FF2B5EF4-FFF2-40B4-BE49-F238E27FC236}">
+                <a16:creationId xmlns:a16="http://schemas.microsoft.com/office/drawing/2014/main" id="{6E22AF92-B9D1-927C-CC9B-8A070F842C51}"/>
+              </a:ext>
+            </a:extLst>
+          </p:cNvPr>
+          <p:cNvSpPr>
+            <a:spLocks noGrp="1"/>
+          </p:cNvSpPr>
+          <p:nvPr>
+            <p:ph idx="1"/>
+          </p:nvPr>
+        </p:nvSpPr>
+        <p:spPr>
+          <a:xfrm>
+            <a:off x="457200" y="1772388"/>
+            <a:ext cx="4386943" cy="4353775"/>
+          </a:xfrm>
+        </p:spPr>
+        <p:txBody>
+          <a:bodyPr/>
+          <a:lstStyle/>
+          <a:p>
+            <a:r>
+              <a:rPr lang="en-US" sz="2300" dirty="0"/>
+              <a:t>A lot of times people are thinking about range maps</a:t>
+            </a:r>
+          </a:p>
+          <a:p>
+            <a:r>
+              <a:rPr lang="en-US" sz="2300" dirty="0"/>
+              <a:t>Scale-dependent, coarse grain, broad extent</a:t>
+            </a:r>
+          </a:p>
+          <a:p>
+            <a:r>
+              <a:rPr lang="en-US" sz="2300" dirty="0"/>
+              <a:t>Presence of individuals, presence of reproductive populations, probability of detection within grid cells or polygons</a:t>
+            </a:r>
+          </a:p>
+          <a:p>
+            <a:endParaRPr lang="en-US" dirty="0"/>
+          </a:p>
+        </p:txBody>
+      </p:sp>
+      <p:pic>
+        <p:nvPicPr>
+          <p:cNvPr id="4" name="Picture 3" descr="Biogeography and species distribution patterns | Evolutionary Biology Class  Notes | Fiveable">
+            <a:extLst>
+              <a:ext uri="{FF2B5EF4-FFF2-40B4-BE49-F238E27FC236}">
+                <a16:creationId xmlns:a16="http://schemas.microsoft.com/office/drawing/2014/main" id="{D8ABB233-EB10-C6AC-1EAD-025831CEDB1E}"/>
+              </a:ext>
+            </a:extLst>
+          </p:cNvPr>
+          <p:cNvPicPr>
+            <a:picLocks noChangeAspect="1"/>
+          </p:cNvPicPr>
+          <p:nvPr/>
+        </p:nvPicPr>
+        <p:blipFill>
+          <a:blip r:embed="rId2"/>
+          <a:stretch>
+            <a:fillRect/>
+          </a:stretch>
+        </p:blipFill>
+        <p:spPr>
+          <a:xfrm>
+            <a:off x="4975103" y="2143125"/>
+            <a:ext cx="3341250" cy="2571750"/>
+          </a:xfrm>
+          <a:prstGeom prst="rect">
+            <a:avLst/>
+          </a:prstGeom>
+        </p:spPr>
+      </p:pic>
+    </p:spTree>
+    <p:extLst>
+      <p:ext uri="{BB962C8B-B14F-4D97-AF65-F5344CB8AC3E}">
+        <p14:creationId xmlns:p14="http://schemas.microsoft.com/office/powerpoint/2010/main" val="390896366"/>
+      </p:ext>
+    </p:extLst>
+  </p:cSld>
+  <p:clrMapOvr>
+    <a:masterClrMapping/>
+  </p:clrMapOvr>
+</p:sld>
+</file>
+
 <file path=ppt/slides/slide2.xml><?xml version="1.0" encoding="utf-8"?>
 <p:sld xmlns:a="http://schemas.openxmlformats.org/drawingml/2006/main" xmlns:r="http://schemas.openxmlformats.org/officeDocument/2006/relationships" xmlns:p="http://schemas.openxmlformats.org/presentationml/2006/main">
   <p:cSld>
@@ -7278,6 +7866,2479 @@
     <p:extLst>
       <p:ext uri="{BB962C8B-B14F-4D97-AF65-F5344CB8AC3E}">
         <p14:creationId xmlns:p14="http://schemas.microsoft.com/office/powerpoint/2010/main" val="1826526696"/>
+      </p:ext>
+    </p:extLst>
+  </p:cSld>
+  <p:clrMapOvr>
+    <a:masterClrMapping/>
+  </p:clrMapOvr>
+</p:sld>
+</file>
+
+<file path=ppt/slides/slide20.xml><?xml version="1.0" encoding="utf-8"?>
+<p:sld xmlns:a="http://schemas.openxmlformats.org/drawingml/2006/main" xmlns:r="http://schemas.openxmlformats.org/officeDocument/2006/relationships" xmlns:p="http://schemas.openxmlformats.org/presentationml/2006/main">
+  <p:cSld>
+    <p:spTree>
+      <p:nvGrpSpPr>
+        <p:cNvPr id="1" name=""/>
+        <p:cNvGrpSpPr/>
+        <p:nvPr/>
+      </p:nvGrpSpPr>
+      <p:grpSpPr>
+        <a:xfrm>
+          <a:off x="0" y="0"/>
+          <a:ext cx="0" cy="0"/>
+          <a:chOff x="0" y="0"/>
+          <a:chExt cx="0" cy="0"/>
+        </a:xfrm>
+      </p:grpSpPr>
+      <p:sp>
+        <p:nvSpPr>
+          <p:cNvPr id="2" name="Title 1">
+            <a:extLst>
+              <a:ext uri="{FF2B5EF4-FFF2-40B4-BE49-F238E27FC236}">
+                <a16:creationId xmlns:a16="http://schemas.microsoft.com/office/drawing/2014/main" id="{FD0A595F-EBDB-9F44-9A9E-B6E6518942E6}"/>
+              </a:ext>
+            </a:extLst>
+          </p:cNvPr>
+          <p:cNvSpPr>
+            <a:spLocks noGrp="1"/>
+          </p:cNvSpPr>
+          <p:nvPr>
+            <p:ph type="title"/>
+          </p:nvPr>
+        </p:nvSpPr>
+        <p:spPr/>
+        <p:txBody>
+          <a:bodyPr>
+            <a:normAutofit/>
+          </a:bodyPr>
+          <a:lstStyle/>
+          <a:p>
+            <a:r>
+              <a:rPr lang="en-US" dirty="0"/>
+              <a:t>Niches and Geographic Distributions</a:t>
+            </a:r>
+          </a:p>
+        </p:txBody>
+      </p:sp>
+      <p:sp>
+        <p:nvSpPr>
+          <p:cNvPr id="3" name="Content Placeholder 2">
+            <a:extLst>
+              <a:ext uri="{FF2B5EF4-FFF2-40B4-BE49-F238E27FC236}">
+                <a16:creationId xmlns:a16="http://schemas.microsoft.com/office/drawing/2014/main" id="{04580947-C9D4-9C42-9C1F-0F68675433E3}"/>
+              </a:ext>
+            </a:extLst>
+          </p:cNvPr>
+          <p:cNvSpPr>
+            <a:spLocks noGrp="1"/>
+          </p:cNvSpPr>
+          <p:nvPr>
+            <p:ph idx="1"/>
+          </p:nvPr>
+        </p:nvSpPr>
+        <p:spPr/>
+        <p:txBody>
+          <a:bodyPr>
+            <a:normAutofit lnSpcReduction="10000"/>
+          </a:bodyPr>
+          <a:lstStyle/>
+          <a:p>
+            <a:r>
+              <a:rPr lang="en-US" dirty="0"/>
+              <a:t>G-space</a:t>
+            </a:r>
+          </a:p>
+          <a:p>
+            <a:pPr lvl="1"/>
+            <a:r>
+              <a:rPr lang="en-US" dirty="0"/>
+              <a:t>Geographic Space</a:t>
+            </a:r>
+          </a:p>
+          <a:p>
+            <a:pPr lvl="1"/>
+            <a:r>
+              <a:rPr lang="en-US" dirty="0"/>
+              <a:t>Represented by points, grid cells, pixels, or polygons</a:t>
+            </a:r>
+          </a:p>
+          <a:p>
+            <a:pPr lvl="1"/>
+            <a:r>
+              <a:rPr lang="en-US" dirty="0"/>
+              <a:t>Broad extent and coarse resolution, typically 1 km</a:t>
+            </a:r>
+            <a:r>
+              <a:rPr lang="en-US" baseline="30000" dirty="0"/>
+              <a:t>2</a:t>
+            </a:r>
+            <a:r>
+              <a:rPr lang="en-US" dirty="0"/>
+              <a:t> per cell or more</a:t>
+            </a:r>
+          </a:p>
+          <a:p>
+            <a:r>
+              <a:rPr lang="en-US" dirty="0"/>
+              <a:t>E-space</a:t>
+            </a:r>
+          </a:p>
+          <a:p>
+            <a:pPr lvl="1"/>
+            <a:r>
+              <a:rPr lang="en-US" dirty="0"/>
+              <a:t>Environmental Space</a:t>
+            </a:r>
+          </a:p>
+          <a:p>
+            <a:pPr lvl="1"/>
+            <a:r>
+              <a:rPr lang="en-US" dirty="0"/>
+              <a:t>Suite of environmental attributes, such as climate, solar radiation, topography, and so on</a:t>
+            </a:r>
+          </a:p>
+          <a:p>
+            <a:pPr lvl="1"/>
+            <a:r>
+              <a:rPr lang="en-US" dirty="0"/>
+              <a:t>Generally characterized in relatively coarse environmental variables</a:t>
+            </a:r>
+          </a:p>
+        </p:txBody>
+      </p:sp>
+    </p:spTree>
+    <p:extLst>
+      <p:ext uri="{BB962C8B-B14F-4D97-AF65-F5344CB8AC3E}">
+        <p14:creationId xmlns:p14="http://schemas.microsoft.com/office/powerpoint/2010/main" val="1438455789"/>
+      </p:ext>
+    </p:extLst>
+  </p:cSld>
+  <p:clrMapOvr>
+    <a:masterClrMapping/>
+  </p:clrMapOvr>
+</p:sld>
+</file>
+
+<file path=ppt/slides/slide21.xml><?xml version="1.0" encoding="utf-8"?>
+<p:sld xmlns:a="http://schemas.openxmlformats.org/drawingml/2006/main" xmlns:r="http://schemas.openxmlformats.org/officeDocument/2006/relationships" xmlns:p="http://schemas.openxmlformats.org/presentationml/2006/main">
+  <p:cSld>
+    <p:spTree>
+      <p:nvGrpSpPr>
+        <p:cNvPr id="1" name=""/>
+        <p:cNvGrpSpPr/>
+        <p:nvPr/>
+      </p:nvGrpSpPr>
+      <p:grpSpPr>
+        <a:xfrm>
+          <a:off x="0" y="0"/>
+          <a:ext cx="0" cy="0"/>
+          <a:chOff x="0" y="0"/>
+          <a:chExt cx="0" cy="0"/>
+        </a:xfrm>
+      </p:grpSpPr>
+      <p:pic>
+        <p:nvPicPr>
+          <p:cNvPr id="4" name="Picture 3">
+            <a:extLst>
+              <a:ext uri="{FF2B5EF4-FFF2-40B4-BE49-F238E27FC236}">
+                <a16:creationId xmlns:a16="http://schemas.microsoft.com/office/drawing/2014/main" id="{C8919133-BF21-0F20-BA1B-C2E6CAB98CC0}"/>
+              </a:ext>
+            </a:extLst>
+          </p:cNvPr>
+          <p:cNvPicPr>
+            <a:picLocks noChangeAspect="1"/>
+          </p:cNvPicPr>
+          <p:nvPr/>
+        </p:nvPicPr>
+        <p:blipFill>
+          <a:blip r:embed="rId2"/>
+          <a:srcRect b="80635"/>
+          <a:stretch>
+            <a:fillRect/>
+          </a:stretch>
+        </p:blipFill>
+        <p:spPr>
+          <a:xfrm>
+            <a:off x="163951" y="1491349"/>
+            <a:ext cx="8472774" cy="1839686"/>
+          </a:xfrm>
+          <a:prstGeom prst="rect">
+            <a:avLst/>
+          </a:prstGeom>
+        </p:spPr>
+      </p:pic>
+      <p:pic>
+        <p:nvPicPr>
+          <p:cNvPr id="5" name="Picture 4">
+            <a:extLst>
+              <a:ext uri="{FF2B5EF4-FFF2-40B4-BE49-F238E27FC236}">
+                <a16:creationId xmlns:a16="http://schemas.microsoft.com/office/drawing/2014/main" id="{96FB802D-711A-06DC-418D-97B8674C45B5}"/>
+              </a:ext>
+            </a:extLst>
+          </p:cNvPr>
+          <p:cNvPicPr>
+            <a:picLocks noChangeAspect="1"/>
+          </p:cNvPicPr>
+          <p:nvPr/>
+        </p:nvPicPr>
+        <p:blipFill>
+          <a:blip r:embed="rId2"/>
+          <a:srcRect t="19594" b="59895"/>
+          <a:stretch>
+            <a:fillRect/>
+          </a:stretch>
+        </p:blipFill>
+        <p:spPr>
+          <a:xfrm>
+            <a:off x="218381" y="3875314"/>
+            <a:ext cx="8472774" cy="1948543"/>
+          </a:xfrm>
+          <a:prstGeom prst="rect">
+            <a:avLst/>
+          </a:prstGeom>
+        </p:spPr>
+      </p:pic>
+      <p:sp>
+        <p:nvSpPr>
+          <p:cNvPr id="6" name="TextBox 5">
+            <a:extLst>
+              <a:ext uri="{FF2B5EF4-FFF2-40B4-BE49-F238E27FC236}">
+                <a16:creationId xmlns:a16="http://schemas.microsoft.com/office/drawing/2014/main" id="{E8D8429D-D791-D409-6A8E-4DAAB04CBBBE}"/>
+              </a:ext>
+            </a:extLst>
+          </p:cNvPr>
+          <p:cNvSpPr txBox="1"/>
+          <p:nvPr/>
+        </p:nvSpPr>
+        <p:spPr>
+          <a:xfrm>
+            <a:off x="1003236" y="6211669"/>
+            <a:ext cx="7525752" cy="461665"/>
+          </a:xfrm>
+          <a:prstGeom prst="rect">
+            <a:avLst/>
+          </a:prstGeom>
+          <a:noFill/>
+        </p:spPr>
+        <p:txBody>
+          <a:bodyPr wrap="square" rtlCol="0">
+            <a:spAutoFit/>
+          </a:bodyPr>
+          <a:lstStyle/>
+          <a:p>
+            <a:r>
+              <a:rPr lang="en-US" sz="1200" dirty="0"/>
+              <a:t>Graham et al. (2025) Biodiversity Patterns Redefined in Environmental Space. </a:t>
+            </a:r>
+            <a:r>
+              <a:rPr lang="en-US" sz="1200" i="1" dirty="0"/>
+              <a:t>Ecology Letters. </a:t>
+            </a:r>
+            <a:r>
+              <a:rPr lang="en-US" sz="1200" dirty="0"/>
+              <a:t>28: e70008.</a:t>
+            </a:r>
+          </a:p>
+          <a:p>
+            <a:endParaRPr lang="en-US" sz="1200" dirty="0"/>
+          </a:p>
+        </p:txBody>
+      </p:sp>
+      <p:sp>
+        <p:nvSpPr>
+          <p:cNvPr id="7" name="Title 1">
+            <a:extLst>
+              <a:ext uri="{FF2B5EF4-FFF2-40B4-BE49-F238E27FC236}">
+                <a16:creationId xmlns:a16="http://schemas.microsoft.com/office/drawing/2014/main" id="{A45FDB01-71C6-7467-989F-616C4CF296E2}"/>
+              </a:ext>
+            </a:extLst>
+          </p:cNvPr>
+          <p:cNvSpPr>
+            <a:spLocks noGrp="1"/>
+          </p:cNvSpPr>
+          <p:nvPr>
+            <p:ph type="title"/>
+          </p:nvPr>
+        </p:nvSpPr>
+        <p:spPr>
+          <a:xfrm>
+            <a:off x="163951" y="348349"/>
+            <a:ext cx="8229600" cy="1143000"/>
+          </a:xfrm>
+        </p:spPr>
+        <p:txBody>
+          <a:bodyPr>
+            <a:normAutofit/>
+          </a:bodyPr>
+          <a:lstStyle/>
+          <a:p>
+            <a:r>
+              <a:rPr lang="en-US" sz="2800" dirty="0"/>
+              <a:t>Hutchinson’s Duality of spaces</a:t>
+            </a:r>
+          </a:p>
+        </p:txBody>
+      </p:sp>
+    </p:spTree>
+    <p:extLst>
+      <p:ext uri="{BB962C8B-B14F-4D97-AF65-F5344CB8AC3E}">
+        <p14:creationId xmlns:p14="http://schemas.microsoft.com/office/powerpoint/2010/main" val="3898966695"/>
+      </p:ext>
+    </p:extLst>
+  </p:cSld>
+  <p:clrMapOvr>
+    <a:masterClrMapping/>
+  </p:clrMapOvr>
+  <p:timing>
+    <p:tnLst>
+      <p:par>
+        <p:cTn id="1" dur="indefinite" restart="never" nodeType="tmRoot">
+          <p:childTnLst>
+            <p:seq concurrent="1" nextAc="seek">
+              <p:cTn id="2" dur="indefinite" nodeType="mainSeq">
+                <p:childTnLst>
+                  <p:par>
+                    <p:cTn id="3" fill="hold">
+                      <p:stCondLst>
+                        <p:cond delay="indefinite"/>
+                      </p:stCondLst>
+                      <p:childTnLst>
+                        <p:par>
+                          <p:cTn id="4" fill="hold">
+                            <p:stCondLst>
+                              <p:cond delay="0"/>
+                            </p:stCondLst>
+                            <p:childTnLst>
+                              <p:par>
+                                <p:cTn id="5" presetID="1" presetClass="entr" presetSubtype="0" fill="hold" nodeType="clickEffect">
+                                  <p:stCondLst>
+                                    <p:cond delay="0"/>
+                                  </p:stCondLst>
+                                  <p:childTnLst>
+                                    <p:set>
+                                      <p:cBhvr>
+                                        <p:cTn id="6" dur="1" fill="hold">
+                                          <p:stCondLst>
+                                            <p:cond delay="0"/>
+                                          </p:stCondLst>
+                                        </p:cTn>
+                                        <p:tgtEl>
+                                          <p:spTgt spid="5"/>
+                                        </p:tgtEl>
+                                        <p:attrNameLst>
+                                          <p:attrName>style.visibility</p:attrName>
+                                        </p:attrNameLst>
+                                      </p:cBhvr>
+                                      <p:to>
+                                        <p:strVal val="visible"/>
+                                      </p:to>
+                                    </p:set>
+                                  </p:childTnLst>
+                                </p:cTn>
+                              </p:par>
+                            </p:childTnLst>
+                          </p:cTn>
+                        </p:par>
+                      </p:childTnLst>
+                    </p:cTn>
+                  </p:par>
+                </p:childTnLst>
+              </p:cTn>
+              <p:prevCondLst>
+                <p:cond evt="onPrev" delay="0">
+                  <p:tgtEl>
+                    <p:sldTgt/>
+                  </p:tgtEl>
+                </p:cond>
+              </p:prevCondLst>
+              <p:nextCondLst>
+                <p:cond evt="onNext" delay="0">
+                  <p:tgtEl>
+                    <p:sldTgt/>
+                  </p:tgtEl>
+                </p:cond>
+              </p:nextCondLst>
+            </p:seq>
+          </p:childTnLst>
+        </p:cTn>
+      </p:par>
+    </p:tnLst>
+  </p:timing>
+</p:sld>
+</file>
+
+<file path=ppt/slides/slide22.xml><?xml version="1.0" encoding="utf-8"?>
+<p:sld xmlns:a="http://schemas.openxmlformats.org/drawingml/2006/main" xmlns:r="http://schemas.openxmlformats.org/officeDocument/2006/relationships" xmlns:p="http://schemas.openxmlformats.org/presentationml/2006/main">
+  <p:cSld>
+    <p:spTree>
+      <p:nvGrpSpPr>
+        <p:cNvPr id="1" name="">
+          <a:extLst>
+            <a:ext uri="{FF2B5EF4-FFF2-40B4-BE49-F238E27FC236}">
+              <a16:creationId xmlns:a16="http://schemas.microsoft.com/office/drawing/2014/main" id="{17626E62-EBD2-ABAD-1EFF-75171648BB50}"/>
+            </a:ext>
+          </a:extLst>
+        </p:cNvPr>
+        <p:cNvGrpSpPr/>
+        <p:nvPr/>
+      </p:nvGrpSpPr>
+      <p:grpSpPr>
+        <a:xfrm>
+          <a:off x="0" y="0"/>
+          <a:ext cx="0" cy="0"/>
+          <a:chOff x="0" y="0"/>
+          <a:chExt cx="0" cy="0"/>
+        </a:xfrm>
+      </p:grpSpPr>
+      <p:pic>
+        <p:nvPicPr>
+          <p:cNvPr id="2" name="Picture 1">
+            <a:extLst>
+              <a:ext uri="{FF2B5EF4-FFF2-40B4-BE49-F238E27FC236}">
+                <a16:creationId xmlns:a16="http://schemas.microsoft.com/office/drawing/2014/main" id="{68ADC4EA-73EB-C0B2-D2F2-345C67C1E1C4}"/>
+              </a:ext>
+            </a:extLst>
+          </p:cNvPr>
+          <p:cNvPicPr>
+            <a:picLocks noChangeAspect="1"/>
+          </p:cNvPicPr>
+          <p:nvPr/>
+        </p:nvPicPr>
+        <p:blipFill>
+          <a:blip r:embed="rId2"/>
+          <a:srcRect l="-1127" t="40907" r="1127" b="19331"/>
+          <a:stretch>
+            <a:fillRect/>
+          </a:stretch>
+        </p:blipFill>
+        <p:spPr>
+          <a:xfrm>
+            <a:off x="335613" y="1540328"/>
+            <a:ext cx="8472774" cy="3777343"/>
+          </a:xfrm>
+          <a:prstGeom prst="rect">
+            <a:avLst/>
+          </a:prstGeom>
+        </p:spPr>
+      </p:pic>
+      <p:sp>
+        <p:nvSpPr>
+          <p:cNvPr id="7" name="TextBox 6">
+            <a:extLst>
+              <a:ext uri="{FF2B5EF4-FFF2-40B4-BE49-F238E27FC236}">
+                <a16:creationId xmlns:a16="http://schemas.microsoft.com/office/drawing/2014/main" id="{72AB99F6-E398-1F9B-FA6F-52EA180AF381}"/>
+              </a:ext>
+            </a:extLst>
+          </p:cNvPr>
+          <p:cNvSpPr txBox="1"/>
+          <p:nvPr/>
+        </p:nvSpPr>
+        <p:spPr>
+          <a:xfrm>
+            <a:off x="1003236" y="6211669"/>
+            <a:ext cx="7525752" cy="461665"/>
+          </a:xfrm>
+          <a:prstGeom prst="rect">
+            <a:avLst/>
+          </a:prstGeom>
+          <a:noFill/>
+        </p:spPr>
+        <p:txBody>
+          <a:bodyPr wrap="square" rtlCol="0">
+            <a:spAutoFit/>
+          </a:bodyPr>
+          <a:lstStyle/>
+          <a:p>
+            <a:r>
+              <a:rPr lang="en-US" sz="1200" dirty="0"/>
+              <a:t>Graham et al. (2025) Biodiversity Patterns Redefined in Environmental Space. </a:t>
+            </a:r>
+            <a:r>
+              <a:rPr lang="en-US" sz="1200" i="1" dirty="0"/>
+              <a:t>Ecology Letters. </a:t>
+            </a:r>
+            <a:r>
+              <a:rPr lang="en-US" sz="1200" dirty="0"/>
+              <a:t>28: e70008.</a:t>
+            </a:r>
+          </a:p>
+          <a:p>
+            <a:endParaRPr lang="en-US" sz="1200" dirty="0"/>
+          </a:p>
+        </p:txBody>
+      </p:sp>
+      <p:sp>
+        <p:nvSpPr>
+          <p:cNvPr id="8" name="Title 1">
+            <a:extLst>
+              <a:ext uri="{FF2B5EF4-FFF2-40B4-BE49-F238E27FC236}">
+                <a16:creationId xmlns:a16="http://schemas.microsoft.com/office/drawing/2014/main" id="{905AF740-3F79-8926-A7BD-C1BA33B92FCD}"/>
+              </a:ext>
+            </a:extLst>
+          </p:cNvPr>
+          <p:cNvSpPr>
+            <a:spLocks noGrp="1"/>
+          </p:cNvSpPr>
+          <p:nvPr>
+            <p:ph type="title"/>
+          </p:nvPr>
+        </p:nvSpPr>
+        <p:spPr>
+          <a:xfrm>
+            <a:off x="163951" y="348349"/>
+            <a:ext cx="8229600" cy="1143000"/>
+          </a:xfrm>
+        </p:spPr>
+        <p:txBody>
+          <a:bodyPr>
+            <a:normAutofit/>
+          </a:bodyPr>
+          <a:lstStyle/>
+          <a:p>
+            <a:r>
+              <a:rPr lang="en-US" sz="2800" dirty="0"/>
+              <a:t>Hutchinson’s Duality of spaces</a:t>
+            </a:r>
+          </a:p>
+        </p:txBody>
+      </p:sp>
+    </p:spTree>
+    <p:extLst>
+      <p:ext uri="{BB962C8B-B14F-4D97-AF65-F5344CB8AC3E}">
+        <p14:creationId xmlns:p14="http://schemas.microsoft.com/office/powerpoint/2010/main" val="2422606917"/>
+      </p:ext>
+    </p:extLst>
+  </p:cSld>
+  <p:clrMapOvr>
+    <a:masterClrMapping/>
+  </p:clrMapOvr>
+</p:sld>
+</file>
+
+<file path=ppt/slides/slide23.xml><?xml version="1.0" encoding="utf-8"?>
+<p:sld xmlns:a="http://schemas.openxmlformats.org/drawingml/2006/main" xmlns:r="http://schemas.openxmlformats.org/officeDocument/2006/relationships" xmlns:p="http://schemas.openxmlformats.org/presentationml/2006/main">
+  <p:cSld>
+    <p:spTree>
+      <p:nvGrpSpPr>
+        <p:cNvPr id="1" name="">
+          <a:extLst>
+            <a:ext uri="{FF2B5EF4-FFF2-40B4-BE49-F238E27FC236}">
+              <a16:creationId xmlns:a16="http://schemas.microsoft.com/office/drawing/2014/main" id="{B7A1DE53-7C3D-02BB-78AD-41D91DF6B4DA}"/>
+            </a:ext>
+          </a:extLst>
+        </p:cNvPr>
+        <p:cNvGrpSpPr/>
+        <p:nvPr/>
+      </p:nvGrpSpPr>
+      <p:grpSpPr>
+        <a:xfrm>
+          <a:off x="0" y="0"/>
+          <a:ext cx="0" cy="0"/>
+          <a:chOff x="0" y="0"/>
+          <a:chExt cx="0" cy="0"/>
+        </a:xfrm>
+      </p:grpSpPr>
+      <p:pic>
+        <p:nvPicPr>
+          <p:cNvPr id="2" name="Picture 1">
+            <a:extLst>
+              <a:ext uri="{FF2B5EF4-FFF2-40B4-BE49-F238E27FC236}">
+                <a16:creationId xmlns:a16="http://schemas.microsoft.com/office/drawing/2014/main" id="{D48B9115-EF56-4D61-5DCE-E4B7124D77EF}"/>
+              </a:ext>
+            </a:extLst>
+          </p:cNvPr>
+          <p:cNvPicPr>
+            <a:picLocks noChangeAspect="1"/>
+          </p:cNvPicPr>
+          <p:nvPr/>
+        </p:nvPicPr>
+        <p:blipFill>
+          <a:blip r:embed="rId2"/>
+          <a:srcRect t="80154" b="-3243"/>
+          <a:stretch>
+            <a:fillRect/>
+          </a:stretch>
+        </p:blipFill>
+        <p:spPr>
+          <a:xfrm>
+            <a:off x="335613" y="2144486"/>
+            <a:ext cx="8472774" cy="2193471"/>
+          </a:xfrm>
+          <a:prstGeom prst="rect">
+            <a:avLst/>
+          </a:prstGeom>
+        </p:spPr>
+      </p:pic>
+      <p:sp>
+        <p:nvSpPr>
+          <p:cNvPr id="3" name="TextBox 2">
+            <a:extLst>
+              <a:ext uri="{FF2B5EF4-FFF2-40B4-BE49-F238E27FC236}">
+                <a16:creationId xmlns:a16="http://schemas.microsoft.com/office/drawing/2014/main" id="{3CE33390-FAD0-4273-D0FB-66AFDDAEF245}"/>
+              </a:ext>
+            </a:extLst>
+          </p:cNvPr>
+          <p:cNvSpPr txBox="1"/>
+          <p:nvPr/>
+        </p:nvSpPr>
+        <p:spPr>
+          <a:xfrm>
+            <a:off x="1003236" y="6211669"/>
+            <a:ext cx="7525752" cy="461665"/>
+          </a:xfrm>
+          <a:prstGeom prst="rect">
+            <a:avLst/>
+          </a:prstGeom>
+          <a:noFill/>
+        </p:spPr>
+        <p:txBody>
+          <a:bodyPr wrap="square" rtlCol="0">
+            <a:spAutoFit/>
+          </a:bodyPr>
+          <a:lstStyle/>
+          <a:p>
+            <a:r>
+              <a:rPr lang="en-US" sz="1200" dirty="0"/>
+              <a:t>Graham et al. (2025) Biodiversity Patterns Redefined in Environmental Space. </a:t>
+            </a:r>
+            <a:r>
+              <a:rPr lang="en-US" sz="1200" i="1" dirty="0"/>
+              <a:t>Ecology Letters. </a:t>
+            </a:r>
+            <a:r>
+              <a:rPr lang="en-US" sz="1200" dirty="0"/>
+              <a:t>28: e70008.</a:t>
+            </a:r>
+          </a:p>
+          <a:p>
+            <a:endParaRPr lang="en-US" sz="1200" dirty="0"/>
+          </a:p>
+        </p:txBody>
+      </p:sp>
+      <p:sp>
+        <p:nvSpPr>
+          <p:cNvPr id="4" name="Title 1">
+            <a:extLst>
+              <a:ext uri="{FF2B5EF4-FFF2-40B4-BE49-F238E27FC236}">
+                <a16:creationId xmlns:a16="http://schemas.microsoft.com/office/drawing/2014/main" id="{DF791C37-DA45-F9D1-20E6-A4A0721ECD4F}"/>
+              </a:ext>
+            </a:extLst>
+          </p:cNvPr>
+          <p:cNvSpPr>
+            <a:spLocks noGrp="1"/>
+          </p:cNvSpPr>
+          <p:nvPr>
+            <p:ph type="title"/>
+          </p:nvPr>
+        </p:nvSpPr>
+        <p:spPr>
+          <a:xfrm>
+            <a:off x="163951" y="348349"/>
+            <a:ext cx="8229600" cy="1143000"/>
+          </a:xfrm>
+        </p:spPr>
+        <p:txBody>
+          <a:bodyPr>
+            <a:normAutofit/>
+          </a:bodyPr>
+          <a:lstStyle/>
+          <a:p>
+            <a:r>
+              <a:rPr lang="en-US" sz="2800" dirty="0"/>
+              <a:t>Biodiversity Patterns in Environmental Space</a:t>
+            </a:r>
+          </a:p>
+        </p:txBody>
+      </p:sp>
+    </p:spTree>
+    <p:extLst>
+      <p:ext uri="{BB962C8B-B14F-4D97-AF65-F5344CB8AC3E}">
+        <p14:creationId xmlns:p14="http://schemas.microsoft.com/office/powerpoint/2010/main" val="3015913218"/>
+      </p:ext>
+    </p:extLst>
+  </p:cSld>
+  <p:clrMapOvr>
+    <a:masterClrMapping/>
+  </p:clrMapOvr>
+</p:sld>
+</file>
+
+<file path=ppt/slides/slide24.xml><?xml version="1.0" encoding="utf-8"?>
+<p:sld xmlns:a="http://schemas.openxmlformats.org/drawingml/2006/main" xmlns:r="http://schemas.openxmlformats.org/officeDocument/2006/relationships" xmlns:p="http://schemas.openxmlformats.org/presentationml/2006/main">
+  <p:cSld>
+    <p:spTree>
+      <p:nvGrpSpPr>
+        <p:cNvPr id="1" name=""/>
+        <p:cNvGrpSpPr/>
+        <p:nvPr/>
+      </p:nvGrpSpPr>
+      <p:grpSpPr>
+        <a:xfrm>
+          <a:off x="0" y="0"/>
+          <a:ext cx="0" cy="0"/>
+          <a:chOff x="0" y="0"/>
+          <a:chExt cx="0" cy="0"/>
+        </a:xfrm>
+      </p:grpSpPr>
+      <p:sp>
+        <p:nvSpPr>
+          <p:cNvPr id="2" name="Title 1">
+            <a:extLst>
+              <a:ext uri="{FF2B5EF4-FFF2-40B4-BE49-F238E27FC236}">
+                <a16:creationId xmlns:a16="http://schemas.microsoft.com/office/drawing/2014/main" id="{605301A5-0B56-CA48-9DC9-1671B4E9951A}"/>
+              </a:ext>
+            </a:extLst>
+          </p:cNvPr>
+          <p:cNvSpPr>
+            <a:spLocks noGrp="1"/>
+          </p:cNvSpPr>
+          <p:nvPr>
+            <p:ph type="title"/>
+          </p:nvPr>
+        </p:nvSpPr>
+        <p:spPr>
+          <a:xfrm>
+            <a:off x="360947" y="184220"/>
+            <a:ext cx="8229600" cy="1143000"/>
+          </a:xfrm>
+        </p:spPr>
+        <p:txBody>
+          <a:bodyPr>
+            <a:normAutofit/>
+          </a:bodyPr>
+          <a:lstStyle/>
+          <a:p>
+            <a:r>
+              <a:rPr lang="en-US" sz="2800" dirty="0"/>
+              <a:t>Hutchinson’s Duality of spaces (Peterson el al. 2011)</a:t>
+            </a:r>
+          </a:p>
+        </p:txBody>
+      </p:sp>
+      <p:pic>
+        <p:nvPicPr>
+          <p:cNvPr id="4" name="Picture 3">
+            <a:extLst>
+              <a:ext uri="{FF2B5EF4-FFF2-40B4-BE49-F238E27FC236}">
+                <a16:creationId xmlns:a16="http://schemas.microsoft.com/office/drawing/2014/main" id="{A88D7618-576E-464D-B2D9-F043FBBC2A46}"/>
+              </a:ext>
+            </a:extLst>
+          </p:cNvPr>
+          <p:cNvPicPr>
+            <a:picLocks noChangeAspect="1"/>
+          </p:cNvPicPr>
+          <p:nvPr/>
+        </p:nvPicPr>
+        <p:blipFill>
+          <a:blip r:embed="rId2"/>
+          <a:stretch>
+            <a:fillRect/>
+          </a:stretch>
+        </p:blipFill>
+        <p:spPr>
+          <a:xfrm>
+            <a:off x="1194702" y="1427429"/>
+            <a:ext cx="6562089" cy="3959249"/>
+          </a:xfrm>
+          <a:prstGeom prst="rect">
+            <a:avLst/>
+          </a:prstGeom>
+        </p:spPr>
+      </p:pic>
+      <p:sp>
+        <p:nvSpPr>
+          <p:cNvPr id="5" name="Rectangle 4">
+            <a:extLst>
+              <a:ext uri="{FF2B5EF4-FFF2-40B4-BE49-F238E27FC236}">
+                <a16:creationId xmlns:a16="http://schemas.microsoft.com/office/drawing/2014/main" id="{55DCEF2B-D7B1-6543-ABB2-A831C529AF3A}"/>
+              </a:ext>
+            </a:extLst>
+          </p:cNvPr>
+          <p:cNvSpPr/>
+          <p:nvPr/>
+        </p:nvSpPr>
+        <p:spPr>
+          <a:xfrm>
+            <a:off x="777043" y="5679394"/>
+            <a:ext cx="2940716" cy="646331"/>
+          </a:xfrm>
+          <a:prstGeom prst="rect">
+            <a:avLst/>
+          </a:prstGeom>
+        </p:spPr>
+        <p:txBody>
+          <a:bodyPr wrap="square">
+            <a:spAutoFit/>
+          </a:bodyPr>
+          <a:lstStyle/>
+          <a:p>
+            <a:pPr marL="285750" indent="-285750">
+              <a:buFont typeface="Arial" panose="020B0604020202020204" pitchFamily="34" charset="0"/>
+              <a:buChar char="•"/>
+            </a:pPr>
+            <a:r>
+              <a:rPr lang="en-US" dirty="0"/>
+              <a:t>Spatial interpolation</a:t>
+            </a:r>
+          </a:p>
+          <a:p>
+            <a:pPr marL="285750" indent="-285750">
+              <a:buFont typeface="Arial" panose="020B0604020202020204" pitchFamily="34" charset="0"/>
+              <a:buChar char="•"/>
+            </a:pPr>
+            <a:r>
+              <a:rPr lang="en-US" dirty="0"/>
+              <a:t>Spatial transferability</a:t>
+            </a:r>
+          </a:p>
+        </p:txBody>
+      </p:sp>
+    </p:spTree>
+    <p:extLst>
+      <p:ext uri="{BB962C8B-B14F-4D97-AF65-F5344CB8AC3E}">
+        <p14:creationId xmlns:p14="http://schemas.microsoft.com/office/powerpoint/2010/main" val="1473415736"/>
+      </p:ext>
+    </p:extLst>
+  </p:cSld>
+  <p:clrMapOvr>
+    <a:masterClrMapping/>
+  </p:clrMapOvr>
+</p:sld>
+</file>
+
+<file path=ppt/slides/slide25.xml><?xml version="1.0" encoding="utf-8"?>
+<p:sld xmlns:a="http://schemas.openxmlformats.org/drawingml/2006/main" xmlns:r="http://schemas.openxmlformats.org/officeDocument/2006/relationships" xmlns:p="http://schemas.openxmlformats.org/presentationml/2006/main">
+  <p:cSld>
+    <p:spTree>
+      <p:nvGrpSpPr>
+        <p:cNvPr id="1" name=""/>
+        <p:cNvGrpSpPr/>
+        <p:nvPr/>
+      </p:nvGrpSpPr>
+      <p:grpSpPr>
+        <a:xfrm>
+          <a:off x="0" y="0"/>
+          <a:ext cx="0" cy="0"/>
+          <a:chOff x="0" y="0"/>
+          <a:chExt cx="0" cy="0"/>
+        </a:xfrm>
+      </p:grpSpPr>
+      <p:sp>
+        <p:nvSpPr>
+          <p:cNvPr id="2" name="Title 1">
+            <a:extLst>
+              <a:ext uri="{FF2B5EF4-FFF2-40B4-BE49-F238E27FC236}">
+                <a16:creationId xmlns:a16="http://schemas.microsoft.com/office/drawing/2014/main" id="{AED42E43-DA69-954D-A956-AE30E630F16E}"/>
+              </a:ext>
+            </a:extLst>
+          </p:cNvPr>
+          <p:cNvSpPr>
+            <a:spLocks noGrp="1"/>
+          </p:cNvSpPr>
+          <p:nvPr>
+            <p:ph type="title"/>
+          </p:nvPr>
+        </p:nvSpPr>
+        <p:spPr/>
+        <p:txBody>
+          <a:bodyPr>
+            <a:normAutofit/>
+          </a:bodyPr>
+          <a:lstStyle/>
+          <a:p>
+            <a:r>
+              <a:rPr lang="en-US" dirty="0"/>
+              <a:t>BAM Diagram (Figure 3.1)</a:t>
+            </a:r>
+          </a:p>
+        </p:txBody>
+      </p:sp>
+      <p:pic>
+        <p:nvPicPr>
+          <p:cNvPr id="4" name="Picture 3">
+            <a:extLst>
+              <a:ext uri="{FF2B5EF4-FFF2-40B4-BE49-F238E27FC236}">
+                <a16:creationId xmlns:a16="http://schemas.microsoft.com/office/drawing/2014/main" id="{7E1F75D3-FEF1-DF4A-AA55-970265D0099D}"/>
+              </a:ext>
+            </a:extLst>
+          </p:cNvPr>
+          <p:cNvPicPr>
+            <a:picLocks noChangeAspect="1"/>
+          </p:cNvPicPr>
+          <p:nvPr/>
+        </p:nvPicPr>
+        <p:blipFill>
+          <a:blip r:embed="rId3"/>
+          <a:stretch>
+            <a:fillRect/>
+          </a:stretch>
+        </p:blipFill>
+        <p:spPr>
+          <a:xfrm>
+            <a:off x="1911350" y="1916018"/>
+            <a:ext cx="5321300" cy="4229100"/>
+          </a:xfrm>
+          <a:prstGeom prst="rect">
+            <a:avLst/>
+          </a:prstGeom>
+        </p:spPr>
+      </p:pic>
+      <p:sp>
+        <p:nvSpPr>
+          <p:cNvPr id="5" name="TextBox 4">
+            <a:extLst>
+              <a:ext uri="{FF2B5EF4-FFF2-40B4-BE49-F238E27FC236}">
+                <a16:creationId xmlns:a16="http://schemas.microsoft.com/office/drawing/2014/main" id="{3B1010B5-C053-994F-8AC3-928CC230181C}"/>
+              </a:ext>
+            </a:extLst>
+          </p:cNvPr>
+          <p:cNvSpPr txBox="1"/>
+          <p:nvPr/>
+        </p:nvSpPr>
+        <p:spPr>
+          <a:xfrm>
+            <a:off x="6795546" y="2552430"/>
+            <a:ext cx="2132956" cy="646331"/>
+          </a:xfrm>
+          <a:prstGeom prst="rect">
+            <a:avLst/>
+          </a:prstGeom>
+          <a:noFill/>
+        </p:spPr>
+        <p:txBody>
+          <a:bodyPr wrap="none" rtlCol="0">
+            <a:spAutoFit/>
+          </a:bodyPr>
+          <a:lstStyle/>
+          <a:p>
+            <a:pPr algn="ctr"/>
+            <a:r>
+              <a:rPr lang="en-US" b="1" dirty="0"/>
+              <a:t>B</a:t>
+            </a:r>
+            <a:r>
+              <a:rPr lang="en-US" dirty="0"/>
+              <a:t> – Favorable Biotic </a:t>
+            </a:r>
+          </a:p>
+          <a:p>
+            <a:pPr algn="ctr"/>
+            <a:r>
+              <a:rPr lang="en-US" dirty="0"/>
+              <a:t>Factors</a:t>
+            </a:r>
+          </a:p>
+        </p:txBody>
+      </p:sp>
+      <p:sp>
+        <p:nvSpPr>
+          <p:cNvPr id="6" name="TextBox 5">
+            <a:extLst>
+              <a:ext uri="{FF2B5EF4-FFF2-40B4-BE49-F238E27FC236}">
+                <a16:creationId xmlns:a16="http://schemas.microsoft.com/office/drawing/2014/main" id="{FDE29863-AB87-954D-B3CC-C0BE3E3CF465}"/>
+              </a:ext>
+            </a:extLst>
+          </p:cNvPr>
+          <p:cNvSpPr txBox="1"/>
+          <p:nvPr/>
+        </p:nvSpPr>
+        <p:spPr>
+          <a:xfrm>
+            <a:off x="6686512" y="4397532"/>
+            <a:ext cx="2362955" cy="369332"/>
+          </a:xfrm>
+          <a:prstGeom prst="rect">
+            <a:avLst/>
+          </a:prstGeom>
+          <a:noFill/>
+        </p:spPr>
+        <p:txBody>
+          <a:bodyPr wrap="none" rtlCol="0">
+            <a:spAutoFit/>
+          </a:bodyPr>
+          <a:lstStyle/>
+          <a:p>
+            <a:r>
+              <a:rPr lang="en-US" b="1" dirty="0"/>
+              <a:t>M</a:t>
+            </a:r>
+            <a:r>
+              <a:rPr lang="en-US" dirty="0"/>
+              <a:t> – Movement Factors</a:t>
+            </a:r>
+          </a:p>
+        </p:txBody>
+      </p:sp>
+      <p:sp>
+        <p:nvSpPr>
+          <p:cNvPr id="7" name="TextBox 6">
+            <a:extLst>
+              <a:ext uri="{FF2B5EF4-FFF2-40B4-BE49-F238E27FC236}">
+                <a16:creationId xmlns:a16="http://schemas.microsoft.com/office/drawing/2014/main" id="{3E6C165E-D6EE-8E42-836B-D530703D30CF}"/>
+              </a:ext>
+            </a:extLst>
+          </p:cNvPr>
+          <p:cNvSpPr txBox="1"/>
+          <p:nvPr/>
+        </p:nvSpPr>
+        <p:spPr>
+          <a:xfrm>
+            <a:off x="6826376" y="3512531"/>
+            <a:ext cx="1925912" cy="369332"/>
+          </a:xfrm>
+          <a:prstGeom prst="rect">
+            <a:avLst/>
+          </a:prstGeom>
+          <a:noFill/>
+        </p:spPr>
+        <p:txBody>
+          <a:bodyPr wrap="none" rtlCol="0">
+            <a:spAutoFit/>
+          </a:bodyPr>
+          <a:lstStyle/>
+          <a:p>
+            <a:r>
+              <a:rPr lang="en-US" b="1" dirty="0"/>
+              <a:t>A</a:t>
+            </a:r>
+            <a:r>
+              <a:rPr lang="en-US" dirty="0"/>
+              <a:t> – Abiotic Factors</a:t>
+            </a:r>
+          </a:p>
+        </p:txBody>
+      </p:sp>
+      <p:sp>
+        <p:nvSpPr>
+          <p:cNvPr id="8" name="TextBox 7">
+            <a:extLst>
+              <a:ext uri="{FF2B5EF4-FFF2-40B4-BE49-F238E27FC236}">
+                <a16:creationId xmlns:a16="http://schemas.microsoft.com/office/drawing/2014/main" id="{66BC8A6A-0120-C544-A6BF-255DA316A4AB}"/>
+              </a:ext>
+            </a:extLst>
+          </p:cNvPr>
+          <p:cNvSpPr txBox="1"/>
+          <p:nvPr/>
+        </p:nvSpPr>
+        <p:spPr>
+          <a:xfrm>
+            <a:off x="315066" y="2237820"/>
+            <a:ext cx="1678729" cy="646331"/>
+          </a:xfrm>
+          <a:prstGeom prst="rect">
+            <a:avLst/>
+          </a:prstGeom>
+          <a:noFill/>
+        </p:spPr>
+        <p:txBody>
+          <a:bodyPr wrap="none" rtlCol="0">
+            <a:spAutoFit/>
+          </a:bodyPr>
+          <a:lstStyle/>
+          <a:p>
+            <a:pPr algn="ctr"/>
+            <a:r>
+              <a:rPr lang="en-US" b="1" dirty="0"/>
+              <a:t>G</a:t>
+            </a:r>
+            <a:r>
+              <a:rPr lang="en-US" dirty="0"/>
+              <a:t> – Geographic </a:t>
+            </a:r>
+          </a:p>
+          <a:p>
+            <a:pPr algn="ctr"/>
+            <a:r>
+              <a:rPr lang="en-US" dirty="0"/>
+              <a:t>Space</a:t>
+            </a:r>
+          </a:p>
+        </p:txBody>
+      </p:sp>
+      <p:sp>
+        <p:nvSpPr>
+          <p:cNvPr id="9" name="TextBox 8">
+            <a:extLst>
+              <a:ext uri="{FF2B5EF4-FFF2-40B4-BE49-F238E27FC236}">
+                <a16:creationId xmlns:a16="http://schemas.microsoft.com/office/drawing/2014/main" id="{33A99E87-8F39-9E46-BFF3-EA12E7D69C4A}"/>
+              </a:ext>
+            </a:extLst>
+          </p:cNvPr>
+          <p:cNvSpPr txBox="1"/>
+          <p:nvPr/>
+        </p:nvSpPr>
+        <p:spPr>
+          <a:xfrm>
+            <a:off x="344914" y="3029762"/>
+            <a:ext cx="1619033" cy="646331"/>
+          </a:xfrm>
+          <a:prstGeom prst="rect">
+            <a:avLst/>
+          </a:prstGeom>
+          <a:noFill/>
+        </p:spPr>
+        <p:txBody>
+          <a:bodyPr wrap="none" rtlCol="0">
+            <a:spAutoFit/>
+          </a:bodyPr>
+          <a:lstStyle/>
+          <a:p>
+            <a:pPr algn="ctr"/>
+            <a:r>
+              <a:rPr lang="en-US" b="1" dirty="0"/>
+              <a:t>G</a:t>
+            </a:r>
+            <a:r>
+              <a:rPr lang="en-US" i="1" baseline="-25000" dirty="0"/>
+              <a:t>A</a:t>
+            </a:r>
+            <a:r>
+              <a:rPr lang="en-US" dirty="0"/>
+              <a:t> – Abiotically</a:t>
+            </a:r>
+          </a:p>
+          <a:p>
+            <a:pPr algn="ctr"/>
+            <a:r>
+              <a:rPr lang="en-US" dirty="0"/>
+              <a:t>Suitable Area</a:t>
+            </a:r>
+          </a:p>
+        </p:txBody>
+      </p:sp>
+      <p:sp>
+        <p:nvSpPr>
+          <p:cNvPr id="10" name="TextBox 9">
+            <a:extLst>
+              <a:ext uri="{FF2B5EF4-FFF2-40B4-BE49-F238E27FC236}">
+                <a16:creationId xmlns:a16="http://schemas.microsoft.com/office/drawing/2014/main" id="{26B4BA8C-E0D6-5945-8521-8E4BBD0835AC}"/>
+              </a:ext>
+            </a:extLst>
+          </p:cNvPr>
+          <p:cNvSpPr txBox="1"/>
+          <p:nvPr/>
+        </p:nvSpPr>
+        <p:spPr>
+          <a:xfrm>
+            <a:off x="180830" y="3821704"/>
+            <a:ext cx="1947201" cy="646331"/>
+          </a:xfrm>
+          <a:prstGeom prst="rect">
+            <a:avLst/>
+          </a:prstGeom>
+          <a:noFill/>
+        </p:spPr>
+        <p:txBody>
+          <a:bodyPr wrap="none" rtlCol="0">
+            <a:spAutoFit/>
+          </a:bodyPr>
+          <a:lstStyle/>
+          <a:p>
+            <a:pPr algn="ctr"/>
+            <a:r>
+              <a:rPr lang="en-US" b="1" dirty="0"/>
+              <a:t>G</a:t>
+            </a:r>
+            <a:r>
+              <a:rPr lang="en-US" b="1" i="1" baseline="-25000" dirty="0"/>
+              <a:t>I</a:t>
+            </a:r>
+            <a:r>
+              <a:rPr lang="en-US" dirty="0"/>
+              <a:t> – Invadable</a:t>
+            </a:r>
+          </a:p>
+          <a:p>
+            <a:pPr algn="ctr"/>
+            <a:r>
+              <a:rPr lang="en-US" dirty="0"/>
+              <a:t>Distributional Area</a:t>
+            </a:r>
+          </a:p>
+        </p:txBody>
+      </p:sp>
+      <p:sp>
+        <p:nvSpPr>
+          <p:cNvPr id="11" name="TextBox 10">
+            <a:extLst>
+              <a:ext uri="{FF2B5EF4-FFF2-40B4-BE49-F238E27FC236}">
+                <a16:creationId xmlns:a16="http://schemas.microsoft.com/office/drawing/2014/main" id="{435D6C01-1CF4-124A-BE2A-A6965C9D1B9E}"/>
+              </a:ext>
+            </a:extLst>
+          </p:cNvPr>
+          <p:cNvSpPr txBox="1"/>
+          <p:nvPr/>
+        </p:nvSpPr>
+        <p:spPr>
+          <a:xfrm>
+            <a:off x="180830" y="4613646"/>
+            <a:ext cx="1947201" cy="646331"/>
+          </a:xfrm>
+          <a:prstGeom prst="rect">
+            <a:avLst/>
+          </a:prstGeom>
+          <a:noFill/>
+        </p:spPr>
+        <p:txBody>
+          <a:bodyPr wrap="none" rtlCol="0">
+            <a:spAutoFit/>
+          </a:bodyPr>
+          <a:lstStyle/>
+          <a:p>
+            <a:pPr algn="ctr"/>
+            <a:r>
+              <a:rPr lang="en-US" b="1" dirty="0"/>
+              <a:t>G</a:t>
+            </a:r>
+            <a:r>
+              <a:rPr lang="en-US" b="1" i="1" baseline="-25000" dirty="0"/>
+              <a:t>o</a:t>
+            </a:r>
+            <a:r>
+              <a:rPr lang="en-US" dirty="0"/>
+              <a:t> – Occupied</a:t>
+            </a:r>
+          </a:p>
+          <a:p>
+            <a:pPr algn="ctr"/>
+            <a:r>
+              <a:rPr lang="en-US" dirty="0"/>
+              <a:t>Distributional Area</a:t>
+            </a:r>
+          </a:p>
+        </p:txBody>
+      </p:sp>
+      <p:sp>
+        <p:nvSpPr>
+          <p:cNvPr id="12" name="Oval 11">
+            <a:extLst>
+              <a:ext uri="{FF2B5EF4-FFF2-40B4-BE49-F238E27FC236}">
+                <a16:creationId xmlns:a16="http://schemas.microsoft.com/office/drawing/2014/main" id="{8A6E94F1-C156-2F40-B205-C2D90D73FFD3}"/>
+              </a:ext>
+            </a:extLst>
+          </p:cNvPr>
+          <p:cNvSpPr/>
+          <p:nvPr/>
+        </p:nvSpPr>
+        <p:spPr>
+          <a:xfrm>
+            <a:off x="6504367" y="1121754"/>
+            <a:ext cx="182145" cy="192505"/>
+          </a:xfrm>
+          <a:prstGeom prst="ellipse">
+            <a:avLst/>
+          </a:prstGeom>
+          <a:solidFill>
+            <a:schemeClr val="tx1"/>
+          </a:solidFill>
+          <a:ln>
+            <a:solidFill>
+              <a:schemeClr val="tx1"/>
+            </a:solidFill>
+          </a:ln>
+        </p:spPr>
+        <p:style>
+          <a:lnRef idx="1">
+            <a:schemeClr val="accent1"/>
+          </a:lnRef>
+          <a:fillRef idx="3">
+            <a:schemeClr val="accent1"/>
+          </a:fillRef>
+          <a:effectRef idx="2">
+            <a:schemeClr val="accent1"/>
+          </a:effectRef>
+          <a:fontRef idx="minor">
+            <a:schemeClr val="lt1"/>
+          </a:fontRef>
+        </p:style>
+        <p:txBody>
+          <a:bodyPr rtlCol="0" anchor="ctr"/>
+          <a:lstStyle/>
+          <a:p>
+            <a:pPr algn="ctr"/>
+            <a:endParaRPr lang="en-US"/>
+          </a:p>
+        </p:txBody>
+      </p:sp>
+      <p:sp>
+        <p:nvSpPr>
+          <p:cNvPr id="13" name="Oval 12">
+            <a:extLst>
+              <a:ext uri="{FF2B5EF4-FFF2-40B4-BE49-F238E27FC236}">
+                <a16:creationId xmlns:a16="http://schemas.microsoft.com/office/drawing/2014/main" id="{93CEA41B-BEB4-4545-9A57-7A3146236C38}"/>
+              </a:ext>
+            </a:extLst>
+          </p:cNvPr>
+          <p:cNvSpPr/>
+          <p:nvPr/>
+        </p:nvSpPr>
+        <p:spPr>
+          <a:xfrm>
+            <a:off x="6504367" y="1439959"/>
+            <a:ext cx="182145" cy="192505"/>
+          </a:xfrm>
+          <a:prstGeom prst="ellipse">
+            <a:avLst/>
+          </a:prstGeom>
+          <a:noFill/>
+          <a:ln>
+            <a:solidFill>
+              <a:schemeClr val="tx1"/>
+            </a:solidFill>
+          </a:ln>
+        </p:spPr>
+        <p:style>
+          <a:lnRef idx="1">
+            <a:schemeClr val="accent1"/>
+          </a:lnRef>
+          <a:fillRef idx="3">
+            <a:schemeClr val="accent1"/>
+          </a:fillRef>
+          <a:effectRef idx="2">
+            <a:schemeClr val="accent1"/>
+          </a:effectRef>
+          <a:fontRef idx="minor">
+            <a:schemeClr val="lt1"/>
+          </a:fontRef>
+        </p:style>
+        <p:txBody>
+          <a:bodyPr rtlCol="0" anchor="ctr"/>
+          <a:lstStyle/>
+          <a:p>
+            <a:pPr algn="ctr"/>
+            <a:endParaRPr lang="en-US" dirty="0"/>
+          </a:p>
+        </p:txBody>
+      </p:sp>
+      <p:sp>
+        <p:nvSpPr>
+          <p:cNvPr id="14" name="TextBox 13">
+            <a:extLst>
+              <a:ext uri="{FF2B5EF4-FFF2-40B4-BE49-F238E27FC236}">
+                <a16:creationId xmlns:a16="http://schemas.microsoft.com/office/drawing/2014/main" id="{EC3CC7D0-E408-094F-9BA9-E7A95306547D}"/>
+              </a:ext>
+            </a:extLst>
+          </p:cNvPr>
+          <p:cNvSpPr txBox="1"/>
+          <p:nvPr/>
+        </p:nvSpPr>
+        <p:spPr>
+          <a:xfrm>
+            <a:off x="6749091" y="1036435"/>
+            <a:ext cx="1036054" cy="369332"/>
+          </a:xfrm>
+          <a:prstGeom prst="rect">
+            <a:avLst/>
+          </a:prstGeom>
+          <a:noFill/>
+        </p:spPr>
+        <p:txBody>
+          <a:bodyPr wrap="none" rtlCol="0">
+            <a:spAutoFit/>
+          </a:bodyPr>
+          <a:lstStyle/>
+          <a:p>
+            <a:pPr algn="ctr"/>
+            <a:r>
+              <a:rPr lang="en-US" dirty="0"/>
+              <a:t>Presence</a:t>
+            </a:r>
+          </a:p>
+        </p:txBody>
+      </p:sp>
+      <p:sp>
+        <p:nvSpPr>
+          <p:cNvPr id="15" name="TextBox 14">
+            <a:extLst>
+              <a:ext uri="{FF2B5EF4-FFF2-40B4-BE49-F238E27FC236}">
+                <a16:creationId xmlns:a16="http://schemas.microsoft.com/office/drawing/2014/main" id="{AEDE9F4D-1FCD-D343-A610-9D9EC74003C9}"/>
+              </a:ext>
+            </a:extLst>
+          </p:cNvPr>
+          <p:cNvSpPr txBox="1"/>
+          <p:nvPr/>
+        </p:nvSpPr>
+        <p:spPr>
+          <a:xfrm>
+            <a:off x="6749091" y="1357430"/>
+            <a:ext cx="978602" cy="369332"/>
+          </a:xfrm>
+          <a:prstGeom prst="rect">
+            <a:avLst/>
+          </a:prstGeom>
+          <a:noFill/>
+        </p:spPr>
+        <p:txBody>
+          <a:bodyPr wrap="none" rtlCol="0">
+            <a:spAutoFit/>
+          </a:bodyPr>
+          <a:lstStyle/>
+          <a:p>
+            <a:pPr algn="ctr"/>
+            <a:r>
+              <a:rPr lang="en-US" dirty="0"/>
+              <a:t>Absence</a:t>
+            </a:r>
+          </a:p>
+        </p:txBody>
+      </p:sp>
+      <p:sp>
+        <p:nvSpPr>
+          <p:cNvPr id="16" name="TextBox 15">
+            <a:extLst>
+              <a:ext uri="{FF2B5EF4-FFF2-40B4-BE49-F238E27FC236}">
+                <a16:creationId xmlns:a16="http://schemas.microsoft.com/office/drawing/2014/main" id="{86A84559-3687-7149-949C-B03D905F3276}"/>
+              </a:ext>
+            </a:extLst>
+          </p:cNvPr>
+          <p:cNvSpPr txBox="1"/>
+          <p:nvPr/>
+        </p:nvSpPr>
+        <p:spPr>
+          <a:xfrm>
+            <a:off x="63907" y="5355367"/>
+            <a:ext cx="2181046" cy="646331"/>
+          </a:xfrm>
+          <a:prstGeom prst="rect">
+            <a:avLst/>
+          </a:prstGeom>
+          <a:noFill/>
+        </p:spPr>
+        <p:txBody>
+          <a:bodyPr wrap="none" rtlCol="0">
+            <a:spAutoFit/>
+          </a:bodyPr>
+          <a:lstStyle/>
+          <a:p>
+            <a:pPr algn="ctr"/>
+            <a:r>
+              <a:rPr lang="en-US" b="1" dirty="0" err="1"/>
+              <a:t>G</a:t>
+            </a:r>
+            <a:r>
+              <a:rPr lang="en-US" b="1" i="1" baseline="-25000" dirty="0" err="1"/>
+              <a:t>p</a:t>
+            </a:r>
+            <a:r>
+              <a:rPr lang="en-US" b="1" i="1" baseline="-25000" dirty="0"/>
+              <a:t> </a:t>
+            </a:r>
+            <a:r>
+              <a:rPr lang="en-US" dirty="0"/>
+              <a:t>– Potential </a:t>
+            </a:r>
+          </a:p>
+          <a:p>
+            <a:pPr algn="ctr"/>
+            <a:r>
+              <a:rPr lang="en-US" dirty="0"/>
+              <a:t>Distribution (</a:t>
+            </a:r>
+            <a:r>
+              <a:rPr lang="en-US" b="1" dirty="0"/>
+              <a:t>G</a:t>
+            </a:r>
+            <a:r>
+              <a:rPr lang="en-US" b="1" i="1" baseline="-25000" dirty="0"/>
+              <a:t>I  </a:t>
+            </a:r>
+            <a:r>
+              <a:rPr lang="en-US" b="1" i="1" dirty="0"/>
+              <a:t>+ </a:t>
+            </a:r>
+            <a:r>
+              <a:rPr lang="en-US" b="1" dirty="0"/>
+              <a:t>G</a:t>
+            </a:r>
+            <a:r>
+              <a:rPr lang="en-US" b="1" i="1" baseline="-25000" dirty="0"/>
+              <a:t>o</a:t>
+            </a:r>
+            <a:r>
+              <a:rPr lang="en-US" dirty="0"/>
+              <a:t>)</a:t>
+            </a:r>
+          </a:p>
+        </p:txBody>
+      </p:sp>
+    </p:spTree>
+    <p:extLst>
+      <p:ext uri="{BB962C8B-B14F-4D97-AF65-F5344CB8AC3E}">
+        <p14:creationId xmlns:p14="http://schemas.microsoft.com/office/powerpoint/2010/main" val="1384353292"/>
+      </p:ext>
+    </p:extLst>
+  </p:cSld>
+  <p:clrMapOvr>
+    <a:masterClrMapping/>
+  </p:clrMapOvr>
+  <p:timing>
+    <p:tnLst>
+      <p:par>
+        <p:cTn id="1" dur="indefinite" restart="never" nodeType="tmRoot">
+          <p:childTnLst>
+            <p:seq concurrent="1" nextAc="seek">
+              <p:cTn id="2" dur="indefinite" nodeType="mainSeq">
+                <p:childTnLst>
+                  <p:par>
+                    <p:cTn id="3" fill="hold">
+                      <p:stCondLst>
+                        <p:cond delay="indefinite"/>
+                      </p:stCondLst>
+                      <p:childTnLst>
+                        <p:par>
+                          <p:cTn id="4" fill="hold">
+                            <p:stCondLst>
+                              <p:cond delay="0"/>
+                            </p:stCondLst>
+                            <p:childTnLst>
+                              <p:par>
+                                <p:cTn id="5" presetID="1" presetClass="entr" presetSubtype="0" fill="hold" grpId="0" nodeType="clickEffect">
+                                  <p:stCondLst>
+                                    <p:cond delay="0"/>
+                                  </p:stCondLst>
+                                  <p:childTnLst>
+                                    <p:set>
+                                      <p:cBhvr>
+                                        <p:cTn id="6" dur="1" fill="hold">
+                                          <p:stCondLst>
+                                            <p:cond delay="0"/>
+                                          </p:stCondLst>
+                                        </p:cTn>
+                                        <p:tgtEl>
+                                          <p:spTgt spid="8"/>
+                                        </p:tgtEl>
+                                        <p:attrNameLst>
+                                          <p:attrName>style.visibility</p:attrName>
+                                        </p:attrNameLst>
+                                      </p:cBhvr>
+                                      <p:to>
+                                        <p:strVal val="visible"/>
+                                      </p:to>
+                                    </p:set>
+                                  </p:childTnLst>
+                                </p:cTn>
+                              </p:par>
+                            </p:childTnLst>
+                          </p:cTn>
+                        </p:par>
+                      </p:childTnLst>
+                    </p:cTn>
+                  </p:par>
+                  <p:par>
+                    <p:cTn id="7" fill="hold">
+                      <p:stCondLst>
+                        <p:cond delay="indefinite"/>
+                      </p:stCondLst>
+                      <p:childTnLst>
+                        <p:par>
+                          <p:cTn id="8" fill="hold">
+                            <p:stCondLst>
+                              <p:cond delay="0"/>
+                            </p:stCondLst>
+                            <p:childTnLst>
+                              <p:par>
+                                <p:cTn id="9" presetID="1" presetClass="entr" presetSubtype="0" fill="hold" grpId="0" nodeType="clickEffect">
+                                  <p:stCondLst>
+                                    <p:cond delay="0"/>
+                                  </p:stCondLst>
+                                  <p:childTnLst>
+                                    <p:set>
+                                      <p:cBhvr>
+                                        <p:cTn id="10" dur="1" fill="hold">
+                                          <p:stCondLst>
+                                            <p:cond delay="0"/>
+                                          </p:stCondLst>
+                                        </p:cTn>
+                                        <p:tgtEl>
+                                          <p:spTgt spid="5"/>
+                                        </p:tgtEl>
+                                        <p:attrNameLst>
+                                          <p:attrName>style.visibility</p:attrName>
+                                        </p:attrNameLst>
+                                      </p:cBhvr>
+                                      <p:to>
+                                        <p:strVal val="visible"/>
+                                      </p:to>
+                                    </p:set>
+                                  </p:childTnLst>
+                                </p:cTn>
+                              </p:par>
+                            </p:childTnLst>
+                          </p:cTn>
+                        </p:par>
+                      </p:childTnLst>
+                    </p:cTn>
+                  </p:par>
+                  <p:par>
+                    <p:cTn id="11" fill="hold">
+                      <p:stCondLst>
+                        <p:cond delay="indefinite"/>
+                      </p:stCondLst>
+                      <p:childTnLst>
+                        <p:par>
+                          <p:cTn id="12" fill="hold">
+                            <p:stCondLst>
+                              <p:cond delay="0"/>
+                            </p:stCondLst>
+                            <p:childTnLst>
+                              <p:par>
+                                <p:cTn id="13" presetID="1" presetClass="entr" presetSubtype="0" fill="hold" grpId="0" nodeType="clickEffect">
+                                  <p:stCondLst>
+                                    <p:cond delay="0"/>
+                                  </p:stCondLst>
+                                  <p:childTnLst>
+                                    <p:set>
+                                      <p:cBhvr>
+                                        <p:cTn id="14" dur="1" fill="hold">
+                                          <p:stCondLst>
+                                            <p:cond delay="0"/>
+                                          </p:stCondLst>
+                                        </p:cTn>
+                                        <p:tgtEl>
+                                          <p:spTgt spid="7"/>
+                                        </p:tgtEl>
+                                        <p:attrNameLst>
+                                          <p:attrName>style.visibility</p:attrName>
+                                        </p:attrNameLst>
+                                      </p:cBhvr>
+                                      <p:to>
+                                        <p:strVal val="visible"/>
+                                      </p:to>
+                                    </p:set>
+                                  </p:childTnLst>
+                                </p:cTn>
+                              </p:par>
+                            </p:childTnLst>
+                          </p:cTn>
+                        </p:par>
+                      </p:childTnLst>
+                    </p:cTn>
+                  </p:par>
+                  <p:par>
+                    <p:cTn id="15" fill="hold">
+                      <p:stCondLst>
+                        <p:cond delay="indefinite"/>
+                      </p:stCondLst>
+                      <p:childTnLst>
+                        <p:par>
+                          <p:cTn id="16" fill="hold">
+                            <p:stCondLst>
+                              <p:cond delay="0"/>
+                            </p:stCondLst>
+                            <p:childTnLst>
+                              <p:par>
+                                <p:cTn id="17" presetID="1" presetClass="entr" presetSubtype="0" fill="hold" grpId="0" nodeType="clickEffect">
+                                  <p:stCondLst>
+                                    <p:cond delay="0"/>
+                                  </p:stCondLst>
+                                  <p:childTnLst>
+                                    <p:set>
+                                      <p:cBhvr>
+                                        <p:cTn id="18" dur="1" fill="hold">
+                                          <p:stCondLst>
+                                            <p:cond delay="0"/>
+                                          </p:stCondLst>
+                                        </p:cTn>
+                                        <p:tgtEl>
+                                          <p:spTgt spid="6"/>
+                                        </p:tgtEl>
+                                        <p:attrNameLst>
+                                          <p:attrName>style.visibility</p:attrName>
+                                        </p:attrNameLst>
+                                      </p:cBhvr>
+                                      <p:to>
+                                        <p:strVal val="visible"/>
+                                      </p:to>
+                                    </p:set>
+                                  </p:childTnLst>
+                                </p:cTn>
+                              </p:par>
+                            </p:childTnLst>
+                          </p:cTn>
+                        </p:par>
+                      </p:childTnLst>
+                    </p:cTn>
+                  </p:par>
+                  <p:par>
+                    <p:cTn id="19" fill="hold">
+                      <p:stCondLst>
+                        <p:cond delay="indefinite"/>
+                      </p:stCondLst>
+                      <p:childTnLst>
+                        <p:par>
+                          <p:cTn id="20" fill="hold">
+                            <p:stCondLst>
+                              <p:cond delay="0"/>
+                            </p:stCondLst>
+                            <p:childTnLst>
+                              <p:par>
+                                <p:cTn id="21" presetID="1" presetClass="entr" presetSubtype="0" fill="hold" grpId="0" nodeType="clickEffect">
+                                  <p:stCondLst>
+                                    <p:cond delay="0"/>
+                                  </p:stCondLst>
+                                  <p:childTnLst>
+                                    <p:set>
+                                      <p:cBhvr>
+                                        <p:cTn id="22" dur="1" fill="hold">
+                                          <p:stCondLst>
+                                            <p:cond delay="0"/>
+                                          </p:stCondLst>
+                                        </p:cTn>
+                                        <p:tgtEl>
+                                          <p:spTgt spid="9"/>
+                                        </p:tgtEl>
+                                        <p:attrNameLst>
+                                          <p:attrName>style.visibility</p:attrName>
+                                        </p:attrNameLst>
+                                      </p:cBhvr>
+                                      <p:to>
+                                        <p:strVal val="visible"/>
+                                      </p:to>
+                                    </p:set>
+                                  </p:childTnLst>
+                                </p:cTn>
+                              </p:par>
+                            </p:childTnLst>
+                          </p:cTn>
+                        </p:par>
+                      </p:childTnLst>
+                    </p:cTn>
+                  </p:par>
+                  <p:par>
+                    <p:cTn id="23" fill="hold">
+                      <p:stCondLst>
+                        <p:cond delay="indefinite"/>
+                      </p:stCondLst>
+                      <p:childTnLst>
+                        <p:par>
+                          <p:cTn id="24" fill="hold">
+                            <p:stCondLst>
+                              <p:cond delay="0"/>
+                            </p:stCondLst>
+                            <p:childTnLst>
+                              <p:par>
+                                <p:cTn id="25" presetID="1" presetClass="entr" presetSubtype="0" fill="hold" grpId="0" nodeType="clickEffect">
+                                  <p:stCondLst>
+                                    <p:cond delay="0"/>
+                                  </p:stCondLst>
+                                  <p:childTnLst>
+                                    <p:set>
+                                      <p:cBhvr>
+                                        <p:cTn id="26" dur="1" fill="hold">
+                                          <p:stCondLst>
+                                            <p:cond delay="0"/>
+                                          </p:stCondLst>
+                                        </p:cTn>
+                                        <p:tgtEl>
+                                          <p:spTgt spid="10"/>
+                                        </p:tgtEl>
+                                        <p:attrNameLst>
+                                          <p:attrName>style.visibility</p:attrName>
+                                        </p:attrNameLst>
+                                      </p:cBhvr>
+                                      <p:to>
+                                        <p:strVal val="visible"/>
+                                      </p:to>
+                                    </p:set>
+                                  </p:childTnLst>
+                                </p:cTn>
+                              </p:par>
+                            </p:childTnLst>
+                          </p:cTn>
+                        </p:par>
+                      </p:childTnLst>
+                    </p:cTn>
+                  </p:par>
+                  <p:par>
+                    <p:cTn id="27" fill="hold">
+                      <p:stCondLst>
+                        <p:cond delay="indefinite"/>
+                      </p:stCondLst>
+                      <p:childTnLst>
+                        <p:par>
+                          <p:cTn id="28" fill="hold">
+                            <p:stCondLst>
+                              <p:cond delay="0"/>
+                            </p:stCondLst>
+                            <p:childTnLst>
+                              <p:par>
+                                <p:cTn id="29" presetID="1" presetClass="entr" presetSubtype="0" fill="hold" grpId="0" nodeType="clickEffect">
+                                  <p:stCondLst>
+                                    <p:cond delay="0"/>
+                                  </p:stCondLst>
+                                  <p:childTnLst>
+                                    <p:set>
+                                      <p:cBhvr>
+                                        <p:cTn id="30" dur="1" fill="hold">
+                                          <p:stCondLst>
+                                            <p:cond delay="0"/>
+                                          </p:stCondLst>
+                                        </p:cTn>
+                                        <p:tgtEl>
+                                          <p:spTgt spid="11"/>
+                                        </p:tgtEl>
+                                        <p:attrNameLst>
+                                          <p:attrName>style.visibility</p:attrName>
+                                        </p:attrNameLst>
+                                      </p:cBhvr>
+                                      <p:to>
+                                        <p:strVal val="visible"/>
+                                      </p:to>
+                                    </p:set>
+                                  </p:childTnLst>
+                                </p:cTn>
+                              </p:par>
+                            </p:childTnLst>
+                          </p:cTn>
+                        </p:par>
+                      </p:childTnLst>
+                    </p:cTn>
+                  </p:par>
+                  <p:par>
+                    <p:cTn id="31" fill="hold">
+                      <p:stCondLst>
+                        <p:cond delay="indefinite"/>
+                      </p:stCondLst>
+                      <p:childTnLst>
+                        <p:par>
+                          <p:cTn id="32" fill="hold">
+                            <p:stCondLst>
+                              <p:cond delay="0"/>
+                            </p:stCondLst>
+                            <p:childTnLst>
+                              <p:par>
+                                <p:cTn id="33" presetID="1" presetClass="entr" presetSubtype="0" fill="hold" grpId="0" nodeType="clickEffect">
+                                  <p:stCondLst>
+                                    <p:cond delay="0"/>
+                                  </p:stCondLst>
+                                  <p:childTnLst>
+                                    <p:set>
+                                      <p:cBhvr>
+                                        <p:cTn id="34" dur="1" fill="hold">
+                                          <p:stCondLst>
+                                            <p:cond delay="0"/>
+                                          </p:stCondLst>
+                                        </p:cTn>
+                                        <p:tgtEl>
+                                          <p:spTgt spid="16"/>
+                                        </p:tgtEl>
+                                        <p:attrNameLst>
+                                          <p:attrName>style.visibility</p:attrName>
+                                        </p:attrNameLst>
+                                      </p:cBhvr>
+                                      <p:to>
+                                        <p:strVal val="visible"/>
+                                      </p:to>
+                                    </p:set>
+                                  </p:childTnLst>
+                                </p:cTn>
+                              </p:par>
+                            </p:childTnLst>
+                          </p:cTn>
+                        </p:par>
+                      </p:childTnLst>
+                    </p:cTn>
+                  </p:par>
+                </p:childTnLst>
+              </p:cTn>
+              <p:prevCondLst>
+                <p:cond evt="onPrev" delay="0">
+                  <p:tgtEl>
+                    <p:sldTgt/>
+                  </p:tgtEl>
+                </p:cond>
+              </p:prevCondLst>
+              <p:nextCondLst>
+                <p:cond evt="onNext" delay="0">
+                  <p:tgtEl>
+                    <p:sldTgt/>
+                  </p:tgtEl>
+                </p:cond>
+              </p:nextCondLst>
+            </p:seq>
+          </p:childTnLst>
+        </p:cTn>
+      </p:par>
+    </p:tnLst>
+    <p:bldLst>
+      <p:bldP spid="5" grpId="0"/>
+      <p:bldP spid="6" grpId="0"/>
+      <p:bldP spid="7" grpId="0"/>
+      <p:bldP spid="8" grpId="0"/>
+      <p:bldP spid="9" grpId="0"/>
+      <p:bldP spid="10" grpId="0"/>
+      <p:bldP spid="11" grpId="0"/>
+      <p:bldP spid="16" grpId="0"/>
+    </p:bldLst>
+  </p:timing>
+</p:sld>
+</file>
+
+<file path=ppt/slides/slide26.xml><?xml version="1.0" encoding="utf-8"?>
+<p:sld xmlns:a="http://schemas.openxmlformats.org/drawingml/2006/main" xmlns:r="http://schemas.openxmlformats.org/officeDocument/2006/relationships" xmlns:p="http://schemas.openxmlformats.org/presentationml/2006/main">
+  <p:cSld>
+    <p:spTree>
+      <p:nvGrpSpPr>
+        <p:cNvPr id="1" name=""/>
+        <p:cNvGrpSpPr/>
+        <p:nvPr/>
+      </p:nvGrpSpPr>
+      <p:grpSpPr>
+        <a:xfrm>
+          <a:off x="0" y="0"/>
+          <a:ext cx="0" cy="0"/>
+          <a:chOff x="0" y="0"/>
+          <a:chExt cx="0" cy="0"/>
+        </a:xfrm>
+      </p:grpSpPr>
+      <p:sp>
+        <p:nvSpPr>
+          <p:cNvPr id="2" name="Title 1">
+            <a:extLst>
+              <a:ext uri="{FF2B5EF4-FFF2-40B4-BE49-F238E27FC236}">
+                <a16:creationId xmlns:a16="http://schemas.microsoft.com/office/drawing/2014/main" id="{AED42E43-DA69-954D-A956-AE30E630F16E}"/>
+              </a:ext>
+            </a:extLst>
+          </p:cNvPr>
+          <p:cNvSpPr>
+            <a:spLocks noGrp="1"/>
+          </p:cNvSpPr>
+          <p:nvPr>
+            <p:ph type="title"/>
+          </p:nvPr>
+        </p:nvSpPr>
+        <p:spPr/>
+        <p:txBody>
+          <a:bodyPr>
+            <a:normAutofit/>
+          </a:bodyPr>
+          <a:lstStyle/>
+          <a:p>
+            <a:r>
+              <a:rPr lang="en-US" dirty="0"/>
+              <a:t>G-space corresponds to E-space</a:t>
+            </a:r>
+          </a:p>
+        </p:txBody>
+      </p:sp>
+      <p:pic>
+        <p:nvPicPr>
+          <p:cNvPr id="4" name="Picture 3">
+            <a:extLst>
+              <a:ext uri="{FF2B5EF4-FFF2-40B4-BE49-F238E27FC236}">
+                <a16:creationId xmlns:a16="http://schemas.microsoft.com/office/drawing/2014/main" id="{11AA08E2-1A16-7F40-9901-CA568DDD4FD0}"/>
+              </a:ext>
+            </a:extLst>
+          </p:cNvPr>
+          <p:cNvPicPr>
+            <a:picLocks noChangeAspect="1"/>
+          </p:cNvPicPr>
+          <p:nvPr/>
+        </p:nvPicPr>
+        <p:blipFill rotWithShape="1">
+          <a:blip r:embed="rId2"/>
+          <a:srcRect b="24892"/>
+          <a:stretch/>
+        </p:blipFill>
+        <p:spPr>
+          <a:xfrm>
+            <a:off x="667843" y="2335801"/>
+            <a:ext cx="7808313" cy="2801688"/>
+          </a:xfrm>
+          <a:prstGeom prst="rect">
+            <a:avLst/>
+          </a:prstGeom>
+        </p:spPr>
+      </p:pic>
+    </p:spTree>
+    <p:extLst>
+      <p:ext uri="{BB962C8B-B14F-4D97-AF65-F5344CB8AC3E}">
+        <p14:creationId xmlns:p14="http://schemas.microsoft.com/office/powerpoint/2010/main" val="143347382"/>
+      </p:ext>
+    </p:extLst>
+  </p:cSld>
+  <p:clrMapOvr>
+    <a:masterClrMapping/>
+  </p:clrMapOvr>
+</p:sld>
+</file>
+
+<file path=ppt/slides/slide27.xml><?xml version="1.0" encoding="utf-8"?>
+<p:sld xmlns:a="http://schemas.openxmlformats.org/drawingml/2006/main" xmlns:r="http://schemas.openxmlformats.org/officeDocument/2006/relationships" xmlns:p="http://schemas.openxmlformats.org/presentationml/2006/main">
+  <p:cSld>
+    <p:spTree>
+      <p:nvGrpSpPr>
+        <p:cNvPr id="1" name=""/>
+        <p:cNvGrpSpPr/>
+        <p:nvPr/>
+      </p:nvGrpSpPr>
+      <p:grpSpPr>
+        <a:xfrm>
+          <a:off x="0" y="0"/>
+          <a:ext cx="0" cy="0"/>
+          <a:chOff x="0" y="0"/>
+          <a:chExt cx="0" cy="0"/>
+        </a:xfrm>
+      </p:grpSpPr>
+      <p:sp>
+        <p:nvSpPr>
+          <p:cNvPr id="2" name="Title 1">
+            <a:extLst>
+              <a:ext uri="{FF2B5EF4-FFF2-40B4-BE49-F238E27FC236}">
+                <a16:creationId xmlns:a16="http://schemas.microsoft.com/office/drawing/2014/main" id="{7F42107D-A96D-64AA-DA75-FA3E4A27816B}"/>
+              </a:ext>
+            </a:extLst>
+          </p:cNvPr>
+          <p:cNvSpPr>
+            <a:spLocks noGrp="1"/>
+          </p:cNvSpPr>
+          <p:nvPr>
+            <p:ph type="title"/>
+          </p:nvPr>
+        </p:nvSpPr>
+        <p:spPr/>
+        <p:txBody>
+          <a:bodyPr/>
+          <a:lstStyle/>
+          <a:p>
+            <a:endParaRPr lang="en-US"/>
+          </a:p>
+        </p:txBody>
+      </p:sp>
+      <p:sp>
+        <p:nvSpPr>
+          <p:cNvPr id="3" name="Content Placeholder 2">
+            <a:extLst>
+              <a:ext uri="{FF2B5EF4-FFF2-40B4-BE49-F238E27FC236}">
+                <a16:creationId xmlns:a16="http://schemas.microsoft.com/office/drawing/2014/main" id="{CB91213E-9BDF-A5F7-33F9-4D03DD5A94BF}"/>
+              </a:ext>
+            </a:extLst>
+          </p:cNvPr>
+          <p:cNvSpPr>
+            <a:spLocks noGrp="1"/>
+          </p:cNvSpPr>
+          <p:nvPr>
+            <p:ph idx="1"/>
+          </p:nvPr>
+        </p:nvSpPr>
+        <p:spPr/>
+        <p:txBody>
+          <a:bodyPr/>
+          <a:lstStyle/>
+          <a:p>
+            <a:endParaRPr lang="en-US"/>
+          </a:p>
+        </p:txBody>
+      </p:sp>
+    </p:spTree>
+    <p:extLst>
+      <p:ext uri="{BB962C8B-B14F-4D97-AF65-F5344CB8AC3E}">
+        <p14:creationId xmlns:p14="http://schemas.microsoft.com/office/powerpoint/2010/main" val="3755365828"/>
+      </p:ext>
+    </p:extLst>
+  </p:cSld>
+  <p:clrMapOvr>
+    <a:masterClrMapping/>
+  </p:clrMapOvr>
+</p:sld>
+</file>
+
+<file path=ppt/slides/slide28.xml><?xml version="1.0" encoding="utf-8"?>
+<p:sld xmlns:a="http://schemas.openxmlformats.org/drawingml/2006/main" xmlns:r="http://schemas.openxmlformats.org/officeDocument/2006/relationships" xmlns:p="http://schemas.openxmlformats.org/presentationml/2006/main">
+  <p:cSld>
+    <p:spTree>
+      <p:nvGrpSpPr>
+        <p:cNvPr id="1" name=""/>
+        <p:cNvGrpSpPr/>
+        <p:nvPr/>
+      </p:nvGrpSpPr>
+      <p:grpSpPr>
+        <a:xfrm>
+          <a:off x="0" y="0"/>
+          <a:ext cx="0" cy="0"/>
+          <a:chOff x="0" y="0"/>
+          <a:chExt cx="0" cy="0"/>
+        </a:xfrm>
+      </p:grpSpPr>
+      <p:sp>
+        <p:nvSpPr>
+          <p:cNvPr id="2" name="Title 1">
+            <a:extLst>
+              <a:ext uri="{FF2B5EF4-FFF2-40B4-BE49-F238E27FC236}">
+                <a16:creationId xmlns:a16="http://schemas.microsoft.com/office/drawing/2014/main" id="{86B456A3-B9F3-C54D-B9F8-24A913A5C563}"/>
+              </a:ext>
+            </a:extLst>
+          </p:cNvPr>
+          <p:cNvSpPr>
+            <a:spLocks noGrp="1"/>
+          </p:cNvSpPr>
+          <p:nvPr>
+            <p:ph type="title"/>
+          </p:nvPr>
+        </p:nvSpPr>
+        <p:spPr/>
+        <p:txBody>
+          <a:bodyPr>
+            <a:normAutofit fontScale="90000"/>
+          </a:bodyPr>
+          <a:lstStyle/>
+          <a:p>
+            <a:r>
+              <a:rPr lang="en-US" dirty="0"/>
+              <a:t>Biotically reduced niche (equivalent to realized niche)</a:t>
+            </a:r>
+          </a:p>
+        </p:txBody>
+      </p:sp>
+      <mc:AlternateContent xmlns:mc="http://schemas.openxmlformats.org/markup-compatibility/2006" xmlns:a14="http://schemas.microsoft.com/office/drawing/2010/main">
+        <mc:Choice Requires="a14">
+          <p:sp>
+            <p:nvSpPr>
+              <p:cNvPr id="6" name="TextBox 5">
+                <a:extLst>
+                  <a:ext uri="{FF2B5EF4-FFF2-40B4-BE49-F238E27FC236}">
+                    <a16:creationId xmlns:a16="http://schemas.microsoft.com/office/drawing/2014/main" id="{8262FF76-0BB1-CB49-9E89-514E3CBA54BA}"/>
+                  </a:ext>
+                </a:extLst>
+              </p:cNvPr>
+              <p:cNvSpPr txBox="1"/>
+              <p:nvPr/>
+            </p:nvSpPr>
+            <p:spPr>
+              <a:xfrm>
+                <a:off x="633024" y="5159137"/>
+                <a:ext cx="7877952" cy="1200329"/>
+              </a:xfrm>
+              <a:prstGeom prst="rect">
+                <a:avLst/>
+              </a:prstGeom>
+              <a:noFill/>
+            </p:spPr>
+            <p:txBody>
+              <a:bodyPr wrap="square" rtlCol="0">
+                <a:spAutoFit/>
+              </a:bodyPr>
+              <a:lstStyle/>
+              <a:p>
+                <a:pPr marL="285750" indent="-285750">
+                  <a:buFont typeface="Arial" panose="020B0604020202020204" pitchFamily="34" charset="0"/>
+                  <a:buChar char="•"/>
+                </a:pPr>
+                <a:r>
+                  <a:rPr lang="en-US" dirty="0"/>
+                  <a:t>Competitive exclusion at local scales might not scale up to influence geographic distributions at broad spatial extents</a:t>
+                </a:r>
+              </a:p>
+              <a:p>
+                <a:pPr marL="285750" indent="-285750">
+                  <a:buFont typeface="Arial" panose="020B0604020202020204" pitchFamily="34" charset="0"/>
+                  <a:buChar char="•"/>
+                </a:pPr>
+                <a:endParaRPr lang="en-US" dirty="0"/>
+              </a:p>
+              <a:p>
+                <a:pPr marL="285750" indent="-285750">
+                  <a:buFont typeface="Arial" panose="020B0604020202020204" pitchFamily="34" charset="0"/>
+                  <a:buChar char="•"/>
+                </a:pPr>
+                <a:r>
+                  <a:rPr lang="en-US" dirty="0" err="1"/>
+                  <a:t>Eltonian</a:t>
+                </a:r>
+                <a:r>
+                  <a:rPr lang="en-US" dirty="0"/>
+                  <a:t> Noise Hypothesis (A</a:t>
+                </a:r>
+                <a14:m>
+                  <m:oMath xmlns:m="http://schemas.openxmlformats.org/officeDocument/2006/math">
+                    <m:r>
+                      <a:rPr lang="en-US" i="1" smtClean="0">
+                        <a:latin typeface="Cambria Math" panose="02040503050406030204" pitchFamily="18" charset="0"/>
+                        <a:ea typeface="Cambria Math" panose="02040503050406030204" pitchFamily="18" charset="0"/>
+                      </a:rPr>
+                      <m:t>≈</m:t>
+                    </m:r>
+                  </m:oMath>
+                </a14:m>
+                <a:r>
+                  <a:rPr lang="en-US" dirty="0"/>
+                  <a:t>B)</a:t>
+                </a:r>
+              </a:p>
+            </p:txBody>
+          </p:sp>
+        </mc:Choice>
+        <mc:Fallback xmlns="">
+          <p:sp>
+            <p:nvSpPr>
+              <p:cNvPr id="6" name="TextBox 5">
+                <a:extLst>
+                  <a:ext uri="{FF2B5EF4-FFF2-40B4-BE49-F238E27FC236}">
+                    <a16:creationId xmlns:a16="http://schemas.microsoft.com/office/drawing/2014/main" id="{8262FF76-0BB1-CB49-9E89-514E3CBA54BA}"/>
+                  </a:ext>
+                </a:extLst>
+              </p:cNvPr>
+              <p:cNvSpPr txBox="1">
+                <a:spLocks noRot="1" noChangeAspect="1" noMove="1" noResize="1" noEditPoints="1" noAdjustHandles="1" noChangeArrowheads="1" noChangeShapeType="1" noTextEdit="1"/>
+              </p:cNvSpPr>
+              <p:nvPr/>
+            </p:nvSpPr>
+            <p:spPr>
+              <a:xfrm>
+                <a:off x="633024" y="5159137"/>
+                <a:ext cx="7877952" cy="1200329"/>
+              </a:xfrm>
+              <a:prstGeom prst="rect">
+                <a:avLst/>
+              </a:prstGeom>
+              <a:blipFill>
+                <a:blip r:embed="rId2"/>
+                <a:stretch>
+                  <a:fillRect l="-322" t="-1042" r="-644" b="-6250"/>
+                </a:stretch>
+              </a:blipFill>
+            </p:spPr>
+            <p:txBody>
+              <a:bodyPr/>
+              <a:lstStyle/>
+              <a:p>
+                <a:r>
+                  <a:rPr lang="en-US">
+                    <a:noFill/>
+                  </a:rPr>
+                  <a:t> </a:t>
+                </a:r>
+              </a:p>
+            </p:txBody>
+          </p:sp>
+        </mc:Fallback>
+      </mc:AlternateContent>
+      <p:pic>
+        <p:nvPicPr>
+          <p:cNvPr id="7" name="Picture 6">
+            <a:extLst>
+              <a:ext uri="{FF2B5EF4-FFF2-40B4-BE49-F238E27FC236}">
+                <a16:creationId xmlns:a16="http://schemas.microsoft.com/office/drawing/2014/main" id="{986E9E05-100B-D346-97C8-B690BD90DEBD}"/>
+              </a:ext>
+            </a:extLst>
+          </p:cNvPr>
+          <p:cNvPicPr>
+            <a:picLocks noChangeAspect="1"/>
+          </p:cNvPicPr>
+          <p:nvPr/>
+        </p:nvPicPr>
+        <p:blipFill>
+          <a:blip r:embed="rId3"/>
+          <a:stretch>
+            <a:fillRect/>
+          </a:stretch>
+        </p:blipFill>
+        <p:spPr>
+          <a:xfrm>
+            <a:off x="1573767" y="1677741"/>
+            <a:ext cx="5385564" cy="2523521"/>
+          </a:xfrm>
+          <a:prstGeom prst="rect">
+            <a:avLst/>
+          </a:prstGeom>
+        </p:spPr>
+      </p:pic>
+      <p:sp>
+        <p:nvSpPr>
+          <p:cNvPr id="8" name="TextBox 7">
+            <a:extLst>
+              <a:ext uri="{FF2B5EF4-FFF2-40B4-BE49-F238E27FC236}">
+                <a16:creationId xmlns:a16="http://schemas.microsoft.com/office/drawing/2014/main" id="{8E5F89AC-66DA-9842-9AFC-0EE42A608A19}"/>
+              </a:ext>
+            </a:extLst>
+          </p:cNvPr>
+          <p:cNvSpPr txBox="1"/>
+          <p:nvPr/>
+        </p:nvSpPr>
+        <p:spPr>
+          <a:xfrm>
+            <a:off x="1802107" y="4217996"/>
+            <a:ext cx="5308555" cy="646331"/>
+          </a:xfrm>
+          <a:prstGeom prst="rect">
+            <a:avLst/>
+          </a:prstGeom>
+          <a:noFill/>
+        </p:spPr>
+        <p:txBody>
+          <a:bodyPr wrap="square" rtlCol="0">
+            <a:spAutoFit/>
+          </a:bodyPr>
+          <a:lstStyle/>
+          <a:p>
+            <a:r>
+              <a:rPr lang="en-US" dirty="0"/>
+              <a:t>Figure 3.3. BAM diagram redrawn to stress differences of spatial resolution in B versus A and M.</a:t>
+            </a:r>
+          </a:p>
+        </p:txBody>
+      </p:sp>
+    </p:spTree>
+    <p:extLst>
+      <p:ext uri="{BB962C8B-B14F-4D97-AF65-F5344CB8AC3E}">
+        <p14:creationId xmlns:p14="http://schemas.microsoft.com/office/powerpoint/2010/main" val="3019300488"/>
+      </p:ext>
+    </p:extLst>
+  </p:cSld>
+  <p:clrMapOvr>
+    <a:masterClrMapping/>
+  </p:clrMapOvr>
+</p:sld>
+</file>
+
+<file path=ppt/slides/slide29.xml><?xml version="1.0" encoding="utf-8"?>
+<p:sld xmlns:a="http://schemas.openxmlformats.org/drawingml/2006/main" xmlns:r="http://schemas.openxmlformats.org/officeDocument/2006/relationships" xmlns:p="http://schemas.openxmlformats.org/presentationml/2006/main">
+  <p:cSld>
+    <p:spTree>
+      <p:nvGrpSpPr>
+        <p:cNvPr id="1" name=""/>
+        <p:cNvGrpSpPr/>
+        <p:nvPr/>
+      </p:nvGrpSpPr>
+      <p:grpSpPr>
+        <a:xfrm>
+          <a:off x="0" y="0"/>
+          <a:ext cx="0" cy="0"/>
+          <a:chOff x="0" y="0"/>
+          <a:chExt cx="0" cy="0"/>
+        </a:xfrm>
+      </p:grpSpPr>
+      <p:sp>
+        <p:nvSpPr>
+          <p:cNvPr id="2" name="Title 1">
+            <a:extLst>
+              <a:ext uri="{FF2B5EF4-FFF2-40B4-BE49-F238E27FC236}">
+                <a16:creationId xmlns:a16="http://schemas.microsoft.com/office/drawing/2014/main" id="{0D886AA2-A749-FC44-A9EA-9E035B5BE80B}"/>
+              </a:ext>
+            </a:extLst>
+          </p:cNvPr>
+          <p:cNvSpPr>
+            <a:spLocks noGrp="1"/>
+          </p:cNvSpPr>
+          <p:nvPr>
+            <p:ph type="title"/>
+          </p:nvPr>
+        </p:nvSpPr>
+        <p:spPr/>
+        <p:txBody>
+          <a:bodyPr>
+            <a:normAutofit/>
+          </a:bodyPr>
+          <a:lstStyle/>
+          <a:p>
+            <a:r>
+              <a:rPr lang="en-US" sz="2600" dirty="0"/>
+              <a:t>Estimating the fundamental niche, mechanistic niche models</a:t>
+            </a:r>
+          </a:p>
+        </p:txBody>
+      </p:sp>
+      <p:sp>
+        <p:nvSpPr>
+          <p:cNvPr id="3" name="Content Placeholder 2">
+            <a:extLst>
+              <a:ext uri="{FF2B5EF4-FFF2-40B4-BE49-F238E27FC236}">
+                <a16:creationId xmlns:a16="http://schemas.microsoft.com/office/drawing/2014/main" id="{45E12713-3B8A-324B-8DA6-A0EF62A47941}"/>
+              </a:ext>
+            </a:extLst>
+          </p:cNvPr>
+          <p:cNvSpPr>
+            <a:spLocks noGrp="1"/>
+          </p:cNvSpPr>
+          <p:nvPr>
+            <p:ph idx="1"/>
+          </p:nvPr>
+        </p:nvSpPr>
+        <p:spPr/>
+        <p:txBody>
+          <a:bodyPr/>
+          <a:lstStyle/>
+          <a:p>
+            <a:r>
+              <a:rPr lang="en-US" sz="2500" dirty="0"/>
+              <a:t>Process-based physiological models</a:t>
+            </a:r>
+          </a:p>
+          <a:p>
+            <a:r>
+              <a:rPr lang="en-US" sz="2500" dirty="0"/>
+              <a:t>First principles of energy transfer and function to describe the ecological physiology of a species</a:t>
+            </a:r>
+          </a:p>
+          <a:p>
+            <a:r>
+              <a:rPr lang="en-US" sz="2500" dirty="0"/>
+              <a:t>Independent of correlative modeling approaches</a:t>
+            </a:r>
+          </a:p>
+          <a:p>
+            <a:r>
+              <a:rPr lang="en-US" sz="2500" dirty="0"/>
+              <a:t>Labor intensive laboratory work, so not readily available for a large number of species</a:t>
+            </a:r>
+          </a:p>
+          <a:p>
+            <a:r>
+              <a:rPr lang="en-US" sz="2500" dirty="0"/>
+              <a:t>Climate variables don’t always represent limiting physiological conditions </a:t>
+            </a:r>
+          </a:p>
+          <a:p>
+            <a:pPr lvl="1"/>
+            <a:endParaRPr lang="en-US" dirty="0"/>
+          </a:p>
+          <a:p>
+            <a:pPr lvl="1"/>
+            <a:endParaRPr lang="en-US" dirty="0"/>
+          </a:p>
+        </p:txBody>
+      </p:sp>
+      <p:sp>
+        <p:nvSpPr>
+          <p:cNvPr id="4" name="TextBox 3">
+            <a:extLst>
+              <a:ext uri="{FF2B5EF4-FFF2-40B4-BE49-F238E27FC236}">
+                <a16:creationId xmlns:a16="http://schemas.microsoft.com/office/drawing/2014/main" id="{5AEEE76C-63EE-5D45-AB4E-BC0BF7CC0630}"/>
+              </a:ext>
+            </a:extLst>
+          </p:cNvPr>
+          <p:cNvSpPr txBox="1"/>
+          <p:nvPr/>
+        </p:nvSpPr>
+        <p:spPr>
+          <a:xfrm>
+            <a:off x="192505" y="6352674"/>
+            <a:ext cx="5693482" cy="369332"/>
+          </a:xfrm>
+          <a:prstGeom prst="rect">
+            <a:avLst/>
+          </a:prstGeom>
+          <a:noFill/>
+        </p:spPr>
+        <p:txBody>
+          <a:bodyPr wrap="none" rtlCol="0">
+            <a:spAutoFit/>
+          </a:bodyPr>
+          <a:lstStyle/>
+          <a:p>
+            <a:r>
+              <a:rPr lang="en-US" dirty="0"/>
+              <a:t>Suggested Reading: Kearney and Porter 2004, Buckley 2008</a:t>
+            </a:r>
+          </a:p>
+        </p:txBody>
+      </p:sp>
+    </p:spTree>
+    <p:extLst>
+      <p:ext uri="{BB962C8B-B14F-4D97-AF65-F5344CB8AC3E}">
+        <p14:creationId xmlns:p14="http://schemas.microsoft.com/office/powerpoint/2010/main" val="1821806023"/>
       </p:ext>
     </p:extLst>
   </p:cSld>
@@ -7571,6 +10632,816 @@
       </p:par>
     </p:tnLst>
   </p:timing>
+</p:sld>
+</file>
+
+<file path=ppt/slides/slide30.xml><?xml version="1.0" encoding="utf-8"?>
+<p:sld xmlns:a="http://schemas.openxmlformats.org/drawingml/2006/main" xmlns:r="http://schemas.openxmlformats.org/officeDocument/2006/relationships" xmlns:p="http://schemas.openxmlformats.org/presentationml/2006/main">
+  <p:cSld>
+    <p:spTree>
+      <p:nvGrpSpPr>
+        <p:cNvPr id="1" name=""/>
+        <p:cNvGrpSpPr/>
+        <p:nvPr/>
+      </p:nvGrpSpPr>
+      <p:grpSpPr>
+        <a:xfrm>
+          <a:off x="0" y="0"/>
+          <a:ext cx="0" cy="0"/>
+          <a:chOff x="0" y="0"/>
+          <a:chExt cx="0" cy="0"/>
+        </a:xfrm>
+      </p:grpSpPr>
+      <p:sp>
+        <p:nvSpPr>
+          <p:cNvPr id="2" name="Title 1">
+            <a:extLst>
+              <a:ext uri="{FF2B5EF4-FFF2-40B4-BE49-F238E27FC236}">
+                <a16:creationId xmlns:a16="http://schemas.microsoft.com/office/drawing/2014/main" id="{0D886AA2-A749-FC44-A9EA-9E035B5BE80B}"/>
+              </a:ext>
+            </a:extLst>
+          </p:cNvPr>
+          <p:cNvSpPr>
+            <a:spLocks noGrp="1"/>
+          </p:cNvSpPr>
+          <p:nvPr>
+            <p:ph type="title"/>
+          </p:nvPr>
+        </p:nvSpPr>
+        <p:spPr/>
+        <p:txBody>
+          <a:bodyPr>
+            <a:normAutofit/>
+          </a:bodyPr>
+          <a:lstStyle/>
+          <a:p>
+            <a:r>
+              <a:rPr lang="en-US" sz="2600" dirty="0"/>
+              <a:t>Estimating the fundamental niche, correlative approach</a:t>
+            </a:r>
+          </a:p>
+        </p:txBody>
+      </p:sp>
+      <p:sp>
+        <p:nvSpPr>
+          <p:cNvPr id="3" name="Content Placeholder 2">
+            <a:extLst>
+              <a:ext uri="{FF2B5EF4-FFF2-40B4-BE49-F238E27FC236}">
+                <a16:creationId xmlns:a16="http://schemas.microsoft.com/office/drawing/2014/main" id="{45E12713-3B8A-324B-8DA6-A0EF62A47941}"/>
+              </a:ext>
+            </a:extLst>
+          </p:cNvPr>
+          <p:cNvSpPr>
+            <a:spLocks noGrp="1"/>
+          </p:cNvSpPr>
+          <p:nvPr>
+            <p:ph idx="1"/>
+          </p:nvPr>
+        </p:nvSpPr>
+        <p:spPr/>
+        <p:txBody>
+          <a:bodyPr>
+            <a:normAutofit/>
+          </a:bodyPr>
+          <a:lstStyle/>
+          <a:p>
+            <a:r>
+              <a:rPr lang="en-US" sz="2500" dirty="0"/>
+              <a:t>Estimate </a:t>
+            </a:r>
+            <a:r>
+              <a:rPr lang="en-US" sz="2500" i="1" dirty="0"/>
+              <a:t>existing</a:t>
+            </a:r>
+            <a:r>
+              <a:rPr lang="en-US" sz="2500" dirty="0"/>
+              <a:t> fundamental niche (E</a:t>
+            </a:r>
+            <a:r>
+              <a:rPr lang="en-US" sz="2500" baseline="-25000" dirty="0"/>
+              <a:t>A</a:t>
+            </a:r>
+            <a:r>
+              <a:rPr lang="en-US" sz="2500" dirty="0"/>
+              <a:t>) from observations of presence of a species in relation to environmental variation</a:t>
+            </a:r>
+          </a:p>
+          <a:p>
+            <a:r>
+              <a:rPr lang="en-US" sz="2500" dirty="0"/>
+              <a:t>Presence-only data</a:t>
+            </a:r>
+          </a:p>
+          <a:p>
+            <a:r>
+              <a:rPr lang="en-US" sz="2500" dirty="0"/>
+              <a:t>Occupied distribution may be reduced from biotic interactions and/or dispersal limitations</a:t>
+            </a:r>
+          </a:p>
+          <a:p>
+            <a:r>
+              <a:rPr lang="en-US" sz="2500" dirty="0"/>
+              <a:t>Thinking about the configuration of BAM is important</a:t>
+            </a:r>
+          </a:p>
+        </p:txBody>
+      </p:sp>
+    </p:spTree>
+    <p:extLst>
+      <p:ext uri="{BB962C8B-B14F-4D97-AF65-F5344CB8AC3E}">
+        <p14:creationId xmlns:p14="http://schemas.microsoft.com/office/powerpoint/2010/main" val="9095451"/>
+      </p:ext>
+    </p:extLst>
+  </p:cSld>
+  <p:clrMapOvr>
+    <a:masterClrMapping/>
+  </p:clrMapOvr>
+</p:sld>
+</file>
+
+<file path=ppt/slides/slide31.xml><?xml version="1.0" encoding="utf-8"?>
+<p:sld xmlns:a="http://schemas.openxmlformats.org/drawingml/2006/main" xmlns:r="http://schemas.openxmlformats.org/officeDocument/2006/relationships" xmlns:p="http://schemas.openxmlformats.org/presentationml/2006/main">
+  <p:cSld>
+    <p:spTree>
+      <p:nvGrpSpPr>
+        <p:cNvPr id="1" name=""/>
+        <p:cNvGrpSpPr/>
+        <p:nvPr/>
+      </p:nvGrpSpPr>
+      <p:grpSpPr>
+        <a:xfrm>
+          <a:off x="0" y="0"/>
+          <a:ext cx="0" cy="0"/>
+          <a:chOff x="0" y="0"/>
+          <a:chExt cx="0" cy="0"/>
+        </a:xfrm>
+      </p:grpSpPr>
+      <p:sp>
+        <p:nvSpPr>
+          <p:cNvPr id="2" name="Title 1">
+            <a:extLst>
+              <a:ext uri="{FF2B5EF4-FFF2-40B4-BE49-F238E27FC236}">
+                <a16:creationId xmlns:a16="http://schemas.microsoft.com/office/drawing/2014/main" id="{D0312CD5-1CC0-8148-9952-E5BA14506D10}"/>
+              </a:ext>
+            </a:extLst>
+          </p:cNvPr>
+          <p:cNvSpPr>
+            <a:spLocks noGrp="1"/>
+          </p:cNvSpPr>
+          <p:nvPr>
+            <p:ph type="title"/>
+          </p:nvPr>
+        </p:nvSpPr>
+        <p:spPr/>
+        <p:txBody>
+          <a:bodyPr>
+            <a:normAutofit/>
+          </a:bodyPr>
+          <a:lstStyle/>
+          <a:p>
+            <a:r>
+              <a:rPr lang="en-US" sz="2800" dirty="0"/>
+              <a:t>Different configurations of BAM</a:t>
+            </a:r>
+          </a:p>
+        </p:txBody>
+      </p:sp>
+      <p:pic>
+        <p:nvPicPr>
+          <p:cNvPr id="4" name="Picture 3">
+            <a:extLst>
+              <a:ext uri="{FF2B5EF4-FFF2-40B4-BE49-F238E27FC236}">
+                <a16:creationId xmlns:a16="http://schemas.microsoft.com/office/drawing/2014/main" id="{AEFDF74E-99B6-9240-980A-571CB497F1E3}"/>
+              </a:ext>
+            </a:extLst>
+          </p:cNvPr>
+          <p:cNvPicPr>
+            <a:picLocks noChangeAspect="1"/>
+          </p:cNvPicPr>
+          <p:nvPr/>
+        </p:nvPicPr>
+        <p:blipFill>
+          <a:blip r:embed="rId2"/>
+          <a:stretch>
+            <a:fillRect/>
+          </a:stretch>
+        </p:blipFill>
+        <p:spPr>
+          <a:xfrm>
+            <a:off x="1624255" y="1772388"/>
+            <a:ext cx="5592678" cy="4660565"/>
+          </a:xfrm>
+          <a:prstGeom prst="rect">
+            <a:avLst/>
+          </a:prstGeom>
+        </p:spPr>
+      </p:pic>
+      <p:sp>
+        <p:nvSpPr>
+          <p:cNvPr id="5" name="TextBox 4">
+            <a:extLst>
+              <a:ext uri="{FF2B5EF4-FFF2-40B4-BE49-F238E27FC236}">
+                <a16:creationId xmlns:a16="http://schemas.microsoft.com/office/drawing/2014/main" id="{A0DB94E7-1CD7-D341-BE37-6B5324BBBE79}"/>
+              </a:ext>
+            </a:extLst>
+          </p:cNvPr>
+          <p:cNvSpPr txBox="1"/>
+          <p:nvPr/>
+        </p:nvSpPr>
+        <p:spPr>
+          <a:xfrm>
+            <a:off x="635668" y="6356822"/>
+            <a:ext cx="1111394" cy="369332"/>
+          </a:xfrm>
+          <a:prstGeom prst="rect">
+            <a:avLst/>
+          </a:prstGeom>
+          <a:noFill/>
+        </p:spPr>
+        <p:txBody>
+          <a:bodyPr wrap="none" rtlCol="0">
+            <a:spAutoFit/>
+          </a:bodyPr>
+          <a:lstStyle/>
+          <a:p>
+            <a:r>
+              <a:rPr lang="en-US" dirty="0"/>
+              <a:t>Figure 3.5</a:t>
+            </a:r>
+          </a:p>
+        </p:txBody>
+      </p:sp>
+      <p:sp>
+        <p:nvSpPr>
+          <p:cNvPr id="6" name="TextBox 5">
+            <a:extLst>
+              <a:ext uri="{FF2B5EF4-FFF2-40B4-BE49-F238E27FC236}">
+                <a16:creationId xmlns:a16="http://schemas.microsoft.com/office/drawing/2014/main" id="{DA678FB8-8DDE-2342-A578-A3588FB4E5B4}"/>
+              </a:ext>
+            </a:extLst>
+          </p:cNvPr>
+          <p:cNvSpPr txBox="1"/>
+          <p:nvPr/>
+        </p:nvSpPr>
+        <p:spPr>
+          <a:xfrm>
+            <a:off x="7078478" y="2453722"/>
+            <a:ext cx="1851661" cy="923330"/>
+          </a:xfrm>
+          <a:prstGeom prst="rect">
+            <a:avLst/>
+          </a:prstGeom>
+          <a:noFill/>
+        </p:spPr>
+        <p:txBody>
+          <a:bodyPr wrap="none" rtlCol="0">
+            <a:spAutoFit/>
+          </a:bodyPr>
+          <a:lstStyle/>
+          <a:p>
+            <a:r>
+              <a:rPr lang="en-US" dirty="0"/>
+              <a:t>No limits on </a:t>
+            </a:r>
+          </a:p>
+          <a:p>
+            <a:r>
+              <a:rPr lang="en-US" dirty="0"/>
+              <a:t>dispersal and</a:t>
+            </a:r>
+          </a:p>
+          <a:p>
+            <a:r>
+              <a:rPr lang="en-US" dirty="0"/>
+              <a:t>biotically reduced</a:t>
+            </a:r>
+          </a:p>
+        </p:txBody>
+      </p:sp>
+      <p:sp>
+        <p:nvSpPr>
+          <p:cNvPr id="7" name="TextBox 6">
+            <a:extLst>
+              <a:ext uri="{FF2B5EF4-FFF2-40B4-BE49-F238E27FC236}">
+                <a16:creationId xmlns:a16="http://schemas.microsoft.com/office/drawing/2014/main" id="{A55BFA5F-CF7F-8149-84A4-81C705AD829C}"/>
+              </a:ext>
+            </a:extLst>
+          </p:cNvPr>
+          <p:cNvSpPr txBox="1"/>
+          <p:nvPr/>
+        </p:nvSpPr>
+        <p:spPr>
+          <a:xfrm>
+            <a:off x="166355" y="4645611"/>
+            <a:ext cx="1508105" cy="923330"/>
+          </a:xfrm>
+          <a:prstGeom prst="rect">
+            <a:avLst/>
+          </a:prstGeom>
+          <a:noFill/>
+        </p:spPr>
+        <p:txBody>
+          <a:bodyPr wrap="none" rtlCol="0">
+            <a:spAutoFit/>
+          </a:bodyPr>
+          <a:lstStyle/>
+          <a:p>
+            <a:r>
+              <a:rPr lang="en-US" dirty="0"/>
+              <a:t>No limits on </a:t>
+            </a:r>
+          </a:p>
+          <a:p>
+            <a:r>
+              <a:rPr lang="en-US" dirty="0"/>
+              <a:t>dispersal and</a:t>
+            </a:r>
+          </a:p>
+          <a:p>
+            <a:r>
+              <a:rPr lang="en-US" dirty="0" err="1"/>
+              <a:t>Eltonian</a:t>
+            </a:r>
+            <a:r>
+              <a:rPr lang="en-US" dirty="0"/>
+              <a:t> noise</a:t>
+            </a:r>
+          </a:p>
+        </p:txBody>
+      </p:sp>
+      <p:sp>
+        <p:nvSpPr>
+          <p:cNvPr id="8" name="TextBox 7">
+            <a:extLst>
+              <a:ext uri="{FF2B5EF4-FFF2-40B4-BE49-F238E27FC236}">
+                <a16:creationId xmlns:a16="http://schemas.microsoft.com/office/drawing/2014/main" id="{A6338D4B-4F3D-A14B-94D8-8359A4F613E2}"/>
+              </a:ext>
+            </a:extLst>
+          </p:cNvPr>
+          <p:cNvSpPr txBox="1"/>
+          <p:nvPr/>
+        </p:nvSpPr>
+        <p:spPr>
+          <a:xfrm>
+            <a:off x="7116523" y="4645611"/>
+            <a:ext cx="1508105" cy="923330"/>
+          </a:xfrm>
+          <a:prstGeom prst="rect">
+            <a:avLst/>
+          </a:prstGeom>
+          <a:noFill/>
+        </p:spPr>
+        <p:txBody>
+          <a:bodyPr wrap="none" rtlCol="0">
+            <a:spAutoFit/>
+          </a:bodyPr>
+          <a:lstStyle/>
+          <a:p>
+            <a:r>
+              <a:rPr lang="en-US" dirty="0"/>
+              <a:t>Limits on </a:t>
+            </a:r>
+          </a:p>
+          <a:p>
+            <a:r>
+              <a:rPr lang="en-US" dirty="0"/>
+              <a:t>dispersal and</a:t>
+            </a:r>
+          </a:p>
+          <a:p>
+            <a:r>
+              <a:rPr lang="en-US" dirty="0" err="1"/>
+              <a:t>Eltonian</a:t>
+            </a:r>
+            <a:r>
+              <a:rPr lang="en-US" dirty="0"/>
+              <a:t> noise</a:t>
+            </a:r>
+          </a:p>
+        </p:txBody>
+      </p:sp>
+      <p:sp>
+        <p:nvSpPr>
+          <p:cNvPr id="9" name="TextBox 8">
+            <a:extLst>
+              <a:ext uri="{FF2B5EF4-FFF2-40B4-BE49-F238E27FC236}">
+                <a16:creationId xmlns:a16="http://schemas.microsoft.com/office/drawing/2014/main" id="{67A0BFA1-1566-B849-A96F-F95DF5750B91}"/>
+              </a:ext>
+            </a:extLst>
+          </p:cNvPr>
+          <p:cNvSpPr txBox="1"/>
+          <p:nvPr/>
+        </p:nvSpPr>
+        <p:spPr>
+          <a:xfrm>
+            <a:off x="96242" y="2315223"/>
+            <a:ext cx="1925055" cy="923330"/>
+          </a:xfrm>
+          <a:prstGeom prst="rect">
+            <a:avLst/>
+          </a:prstGeom>
+          <a:noFill/>
+        </p:spPr>
+        <p:txBody>
+          <a:bodyPr wrap="square" rtlCol="0">
+            <a:spAutoFit/>
+          </a:bodyPr>
+          <a:lstStyle/>
+          <a:p>
+            <a:r>
+              <a:rPr lang="en-US" dirty="0"/>
+              <a:t>Limits on dispersal and biotically reduced</a:t>
+            </a:r>
+          </a:p>
+        </p:txBody>
+      </p:sp>
+    </p:spTree>
+    <p:extLst>
+      <p:ext uri="{BB962C8B-B14F-4D97-AF65-F5344CB8AC3E}">
+        <p14:creationId xmlns:p14="http://schemas.microsoft.com/office/powerpoint/2010/main" val="3552569751"/>
+      </p:ext>
+    </p:extLst>
+  </p:cSld>
+  <p:clrMapOvr>
+    <a:masterClrMapping/>
+  </p:clrMapOvr>
+  <p:timing>
+    <p:tnLst>
+      <p:par>
+        <p:cTn id="1" dur="indefinite" restart="never" nodeType="tmRoot">
+          <p:childTnLst>
+            <p:seq concurrent="1" nextAc="seek">
+              <p:cTn id="2" dur="indefinite" nodeType="mainSeq">
+                <p:childTnLst>
+                  <p:par>
+                    <p:cTn id="3" fill="hold">
+                      <p:stCondLst>
+                        <p:cond delay="indefinite"/>
+                      </p:stCondLst>
+                      <p:childTnLst>
+                        <p:par>
+                          <p:cTn id="4" fill="hold">
+                            <p:stCondLst>
+                              <p:cond delay="0"/>
+                            </p:stCondLst>
+                            <p:childTnLst>
+                              <p:par>
+                                <p:cTn id="5" presetID="1" presetClass="entr" presetSubtype="0" fill="hold" grpId="0" nodeType="clickEffect">
+                                  <p:stCondLst>
+                                    <p:cond delay="0"/>
+                                  </p:stCondLst>
+                                  <p:childTnLst>
+                                    <p:set>
+                                      <p:cBhvr>
+                                        <p:cTn id="6" dur="1" fill="hold">
+                                          <p:stCondLst>
+                                            <p:cond delay="0"/>
+                                          </p:stCondLst>
+                                        </p:cTn>
+                                        <p:tgtEl>
+                                          <p:spTgt spid="9"/>
+                                        </p:tgtEl>
+                                        <p:attrNameLst>
+                                          <p:attrName>style.visibility</p:attrName>
+                                        </p:attrNameLst>
+                                      </p:cBhvr>
+                                      <p:to>
+                                        <p:strVal val="visible"/>
+                                      </p:to>
+                                    </p:set>
+                                  </p:childTnLst>
+                                </p:cTn>
+                              </p:par>
+                            </p:childTnLst>
+                          </p:cTn>
+                        </p:par>
+                      </p:childTnLst>
+                    </p:cTn>
+                  </p:par>
+                  <p:par>
+                    <p:cTn id="7" fill="hold">
+                      <p:stCondLst>
+                        <p:cond delay="indefinite"/>
+                      </p:stCondLst>
+                      <p:childTnLst>
+                        <p:par>
+                          <p:cTn id="8" fill="hold">
+                            <p:stCondLst>
+                              <p:cond delay="0"/>
+                            </p:stCondLst>
+                            <p:childTnLst>
+                              <p:par>
+                                <p:cTn id="9" presetID="1" presetClass="entr" presetSubtype="0" fill="hold" grpId="0" nodeType="clickEffect">
+                                  <p:stCondLst>
+                                    <p:cond delay="0"/>
+                                  </p:stCondLst>
+                                  <p:childTnLst>
+                                    <p:set>
+                                      <p:cBhvr>
+                                        <p:cTn id="10" dur="1" fill="hold">
+                                          <p:stCondLst>
+                                            <p:cond delay="0"/>
+                                          </p:stCondLst>
+                                        </p:cTn>
+                                        <p:tgtEl>
+                                          <p:spTgt spid="6"/>
+                                        </p:tgtEl>
+                                        <p:attrNameLst>
+                                          <p:attrName>style.visibility</p:attrName>
+                                        </p:attrNameLst>
+                                      </p:cBhvr>
+                                      <p:to>
+                                        <p:strVal val="visible"/>
+                                      </p:to>
+                                    </p:set>
+                                  </p:childTnLst>
+                                </p:cTn>
+                              </p:par>
+                            </p:childTnLst>
+                          </p:cTn>
+                        </p:par>
+                      </p:childTnLst>
+                    </p:cTn>
+                  </p:par>
+                  <p:par>
+                    <p:cTn id="11" fill="hold">
+                      <p:stCondLst>
+                        <p:cond delay="indefinite"/>
+                      </p:stCondLst>
+                      <p:childTnLst>
+                        <p:par>
+                          <p:cTn id="12" fill="hold">
+                            <p:stCondLst>
+                              <p:cond delay="0"/>
+                            </p:stCondLst>
+                            <p:childTnLst>
+                              <p:par>
+                                <p:cTn id="13" presetID="1" presetClass="entr" presetSubtype="0" fill="hold" grpId="0" nodeType="clickEffect">
+                                  <p:stCondLst>
+                                    <p:cond delay="0"/>
+                                  </p:stCondLst>
+                                  <p:childTnLst>
+                                    <p:set>
+                                      <p:cBhvr>
+                                        <p:cTn id="14" dur="1" fill="hold">
+                                          <p:stCondLst>
+                                            <p:cond delay="0"/>
+                                          </p:stCondLst>
+                                        </p:cTn>
+                                        <p:tgtEl>
+                                          <p:spTgt spid="7"/>
+                                        </p:tgtEl>
+                                        <p:attrNameLst>
+                                          <p:attrName>style.visibility</p:attrName>
+                                        </p:attrNameLst>
+                                      </p:cBhvr>
+                                      <p:to>
+                                        <p:strVal val="visible"/>
+                                      </p:to>
+                                    </p:set>
+                                  </p:childTnLst>
+                                </p:cTn>
+                              </p:par>
+                            </p:childTnLst>
+                          </p:cTn>
+                        </p:par>
+                      </p:childTnLst>
+                    </p:cTn>
+                  </p:par>
+                  <p:par>
+                    <p:cTn id="15" fill="hold">
+                      <p:stCondLst>
+                        <p:cond delay="indefinite"/>
+                      </p:stCondLst>
+                      <p:childTnLst>
+                        <p:par>
+                          <p:cTn id="16" fill="hold">
+                            <p:stCondLst>
+                              <p:cond delay="0"/>
+                            </p:stCondLst>
+                            <p:childTnLst>
+                              <p:par>
+                                <p:cTn id="17" presetID="1" presetClass="entr" presetSubtype="0" fill="hold" grpId="0" nodeType="clickEffect">
+                                  <p:stCondLst>
+                                    <p:cond delay="0"/>
+                                  </p:stCondLst>
+                                  <p:childTnLst>
+                                    <p:set>
+                                      <p:cBhvr>
+                                        <p:cTn id="18" dur="1" fill="hold">
+                                          <p:stCondLst>
+                                            <p:cond delay="0"/>
+                                          </p:stCondLst>
+                                        </p:cTn>
+                                        <p:tgtEl>
+                                          <p:spTgt spid="8"/>
+                                        </p:tgtEl>
+                                        <p:attrNameLst>
+                                          <p:attrName>style.visibility</p:attrName>
+                                        </p:attrNameLst>
+                                      </p:cBhvr>
+                                      <p:to>
+                                        <p:strVal val="visible"/>
+                                      </p:to>
+                                    </p:set>
+                                  </p:childTnLst>
+                                </p:cTn>
+                              </p:par>
+                            </p:childTnLst>
+                          </p:cTn>
+                        </p:par>
+                      </p:childTnLst>
+                    </p:cTn>
+                  </p:par>
+                </p:childTnLst>
+              </p:cTn>
+              <p:prevCondLst>
+                <p:cond evt="onPrev" delay="0">
+                  <p:tgtEl>
+                    <p:sldTgt/>
+                  </p:tgtEl>
+                </p:cond>
+              </p:prevCondLst>
+              <p:nextCondLst>
+                <p:cond evt="onNext" delay="0">
+                  <p:tgtEl>
+                    <p:sldTgt/>
+                  </p:tgtEl>
+                </p:cond>
+              </p:nextCondLst>
+            </p:seq>
+          </p:childTnLst>
+        </p:cTn>
+      </p:par>
+    </p:tnLst>
+    <p:bldLst>
+      <p:bldP spid="6" grpId="0"/>
+      <p:bldP spid="7" grpId="0"/>
+      <p:bldP spid="8" grpId="0"/>
+      <p:bldP spid="9" grpId="0"/>
+    </p:bldLst>
+  </p:timing>
+</p:sld>
+</file>
+
+<file path=ppt/slides/slide32.xml><?xml version="1.0" encoding="utf-8"?>
+<p:sld xmlns:a="http://schemas.openxmlformats.org/drawingml/2006/main" xmlns:r="http://schemas.openxmlformats.org/officeDocument/2006/relationships" xmlns:p="http://schemas.openxmlformats.org/presentationml/2006/main">
+  <p:cSld>
+    <p:spTree>
+      <p:nvGrpSpPr>
+        <p:cNvPr id="1" name=""/>
+        <p:cNvGrpSpPr/>
+        <p:nvPr/>
+      </p:nvGrpSpPr>
+      <p:grpSpPr>
+        <a:xfrm>
+          <a:off x="0" y="0"/>
+          <a:ext cx="0" cy="0"/>
+          <a:chOff x="0" y="0"/>
+          <a:chExt cx="0" cy="0"/>
+        </a:xfrm>
+      </p:grpSpPr>
+      <p:sp>
+        <p:nvSpPr>
+          <p:cNvPr id="2" name="Title 1">
+            <a:extLst>
+              <a:ext uri="{FF2B5EF4-FFF2-40B4-BE49-F238E27FC236}">
+                <a16:creationId xmlns:a16="http://schemas.microsoft.com/office/drawing/2014/main" id="{AFDE41BE-F0D3-AC47-B8CD-664164EF0A8C}"/>
+              </a:ext>
+            </a:extLst>
+          </p:cNvPr>
+          <p:cNvSpPr>
+            <a:spLocks noGrp="1"/>
+          </p:cNvSpPr>
+          <p:nvPr>
+            <p:ph type="title"/>
+          </p:nvPr>
+        </p:nvSpPr>
+        <p:spPr>
+          <a:xfrm>
+            <a:off x="457200" y="352658"/>
+            <a:ext cx="8229600" cy="1143000"/>
+          </a:xfrm>
+        </p:spPr>
+        <p:txBody>
+          <a:bodyPr>
+            <a:normAutofit/>
+          </a:bodyPr>
+          <a:lstStyle/>
+          <a:p>
+            <a:r>
+              <a:rPr lang="en-US" sz="2800" dirty="0"/>
+              <a:t>Occurrence data</a:t>
+            </a:r>
+          </a:p>
+        </p:txBody>
+      </p:sp>
+      <p:sp>
+        <p:nvSpPr>
+          <p:cNvPr id="3" name="Content Placeholder 2">
+            <a:extLst>
+              <a:ext uri="{FF2B5EF4-FFF2-40B4-BE49-F238E27FC236}">
+                <a16:creationId xmlns:a16="http://schemas.microsoft.com/office/drawing/2014/main" id="{B80CBE24-690F-6441-BC21-664B9A47DA3C}"/>
+              </a:ext>
+            </a:extLst>
+          </p:cNvPr>
+          <p:cNvSpPr>
+            <a:spLocks noGrp="1"/>
+          </p:cNvSpPr>
+          <p:nvPr>
+            <p:ph idx="1"/>
+          </p:nvPr>
+        </p:nvSpPr>
+        <p:spPr>
+          <a:xfrm>
+            <a:off x="457200" y="1495658"/>
+            <a:ext cx="8229600" cy="4353775"/>
+          </a:xfrm>
+        </p:spPr>
+        <p:txBody>
+          <a:bodyPr/>
+          <a:lstStyle/>
+          <a:p>
+            <a:r>
+              <a:rPr lang="en-US" sz="2600" dirty="0"/>
+              <a:t>When “true” absences are known</a:t>
+            </a:r>
+          </a:p>
+          <a:p>
+            <a:pPr lvl="1"/>
+            <a:r>
+              <a:rPr lang="en-US" dirty="0"/>
+              <a:t>Typical statistical methods</a:t>
+            </a:r>
+          </a:p>
+          <a:p>
+            <a:pPr lvl="2"/>
+            <a:r>
+              <a:rPr lang="en-US" dirty="0"/>
+              <a:t>Generalized Linear Modeling (GLM)</a:t>
+            </a:r>
+          </a:p>
+          <a:p>
+            <a:pPr lvl="2"/>
+            <a:r>
+              <a:rPr lang="en-US" dirty="0"/>
+              <a:t>Generalized Additive Modeling (GAM)</a:t>
+            </a:r>
+          </a:p>
+          <a:p>
+            <a:pPr lvl="2"/>
+            <a:r>
+              <a:rPr lang="en-US" dirty="0"/>
+              <a:t>Regression Trees</a:t>
+            </a:r>
+          </a:p>
+          <a:p>
+            <a:pPr lvl="1"/>
+            <a:r>
+              <a:rPr lang="en-US" dirty="0"/>
+              <a:t>Models calibrated with presence and absence data are Species Distribution Models (SDM)</a:t>
+            </a:r>
+          </a:p>
+          <a:p>
+            <a:r>
+              <a:rPr lang="en-US" sz="2500" dirty="0"/>
+              <a:t>Most biodiversity datasets are presence-only data</a:t>
+            </a:r>
+          </a:p>
+          <a:p>
+            <a:pPr lvl="1"/>
+            <a:r>
+              <a:rPr lang="en-US" dirty="0"/>
+              <a:t>Finding similar E to occupied E (E</a:t>
+            </a:r>
+            <a:r>
+              <a:rPr lang="en-US" baseline="-25000" dirty="0"/>
+              <a:t>O</a:t>
+            </a:r>
+            <a:r>
+              <a:rPr lang="en-US" dirty="0"/>
+              <a:t>) in G-space</a:t>
+            </a:r>
+          </a:p>
+          <a:p>
+            <a:pPr lvl="1"/>
+            <a:r>
+              <a:rPr lang="en-US" dirty="0"/>
+              <a:t>Ecological Niche Modeling (ENM)</a:t>
+            </a:r>
+          </a:p>
+        </p:txBody>
+      </p:sp>
+    </p:spTree>
+    <p:extLst>
+      <p:ext uri="{BB962C8B-B14F-4D97-AF65-F5344CB8AC3E}">
+        <p14:creationId xmlns:p14="http://schemas.microsoft.com/office/powerpoint/2010/main" val="566980777"/>
+      </p:ext>
+    </p:extLst>
+  </p:cSld>
+  <p:clrMapOvr>
+    <a:masterClrMapping/>
+  </p:clrMapOvr>
 </p:sld>
 </file>
 
@@ -8742,7 +12613,7 @@
                   </a:schemeClr>
                 </a:solidFill>
               </a:rPr>
-              <a:t>Good habitats to start - pull before you start working and commit/push when you are done</a:t>
+              <a:t>Good habits to start - pull before you start working and commit/push when you are done</a:t>
             </a:r>
           </a:p>
         </p:txBody>

</xml_diff>